<commit_message>
fix: populate PPTX slides from hidden deck sections
Extract text from visibility:hidden slides in document order, improve PPTX text layout, and regenerate Logo Design pilot exports so cached decks include full slide content.

Co-authored-by: Cursor <cursoragent@cursor.com>
</commit_message>
<xml_diff>
--- a/public/assets/editable/professional-logo-design-sales-presentation-2/de/Professional Logo Design Sales Presentation - de.pptx
+++ b/public/assets/editable/professional-logo-design-sales-presentation-2/de/Professional Logo Design Sales Presentation - de.pptx
@@ -2030,16 +2030,59 @@
         <p:spPr>
           <a:xfrm>
             <a:off x="457200" y="868680"/>
-            <a:ext cx="10972800" cy="594360"/>
-          </a:xfrm>
-          <a:prstGeom prst="rect">
-            <a:avLst/>
-          </a:prstGeom>
-          <a:noFill/>
-          <a:ln/>
-        </p:spPr>
-        <p:txBody>
-          <a:bodyPr wrap="square" rtlCol="0" anchor="ctr"/>
+            <a:ext cx="6949440" cy="502920"/>
+          </a:xfrm>
+          <a:prstGeom prst="rect">
+            <a:avLst/>
+          </a:prstGeom>
+          <a:noFill/>
+          <a:ln/>
+        </p:spPr>
+        <p:txBody>
+          <a:bodyPr wrap="square" rtlCol="0" anchor="t">
+            <a:normAutofit/>
+          </a:bodyPr>
+          <a:lstStyle/>
+          <a:p>
+            <a:pPr indent="0" marL="0">
+              <a:buNone/>
+            </a:pPr>
+            <a:r>
+              <a:rPr lang="en-US" sz="2200" b="1" dirty="0">
+                <a:solidFill>
+                  <a:srgbClr val="1A1A1A"/>
+                </a:solidFill>
+                <a:latin typeface="Arial" pitchFamily="34" charset="0"/>
+                <a:ea typeface="Arial" pitchFamily="34" charset="-122"/>
+                <a:cs typeface="Arial" pitchFamily="34" charset="-120"/>
+              </a:rPr>
+              <a:t>Professionelles Logo-Design</a:t>
+            </a:r>
+            <a:endParaRPr lang="en-US" sz="2200" dirty="0"/>
+          </a:p>
+        </p:txBody>
+      </p:sp>
+      <p:sp>
+        <p:nvSpPr>
+          <p:cNvPr id="5" name="Text 3"/>
+          <p:cNvSpPr/>
+          <p:nvPr/>
+        </p:nvSpPr>
+        <p:spPr>
+          <a:xfrm>
+            <a:off x="457200" y="1481328"/>
+            <a:ext cx="6949440" cy="1176528"/>
+          </a:xfrm>
+          <a:prstGeom prst="rect">
+            <a:avLst/>
+          </a:prstGeom>
+          <a:noFill/>
+          <a:ln/>
+        </p:spPr>
+        <p:txBody>
+          <a:bodyPr wrap="square" rtlCol="0" anchor="t">
+            <a:normAutofit/>
+          </a:bodyPr>
           <a:lstStyle/>
           <a:p>
             <a:pPr indent="0" marL="0">
@@ -2062,62 +2105,25 @@
       </p:sp>
       <p:sp>
         <p:nvSpPr>
-          <p:cNvPr id="5" name="Text 3"/>
-          <p:cNvSpPr/>
-          <p:nvPr/>
-        </p:nvSpPr>
-        <p:spPr>
-          <a:xfrm>
-            <a:off x="457200" y="1645920"/>
-            <a:ext cx="10972800" cy="594360"/>
-          </a:xfrm>
-          <a:prstGeom prst="rect">
-            <a:avLst/>
-          </a:prstGeom>
-          <a:noFill/>
-          <a:ln/>
-        </p:spPr>
-        <p:txBody>
-          <a:bodyPr wrap="square" rtlCol="0" anchor="ctr"/>
-          <a:lstStyle/>
-          <a:p>
-            <a:pPr indent="0" marL="0">
-              <a:buNone/>
-            </a:pPr>
-            <a:r>
-              <a:rPr lang="en-US" sz="2200" b="1" dirty="0">
-                <a:solidFill>
-                  <a:srgbClr val="1A1A1A"/>
-                </a:solidFill>
-                <a:latin typeface="Arial" pitchFamily="34" charset="0"/>
-                <a:ea typeface="Arial" pitchFamily="34" charset="-122"/>
-                <a:cs typeface="Arial" pitchFamily="34" charset="-120"/>
-              </a:rPr>
-              <a:t>PROFESSIONELLES LOGO-DESIGN</a:t>
-            </a:r>
-            <a:endParaRPr lang="en-US" sz="2200" dirty="0"/>
-          </a:p>
-        </p:txBody>
-      </p:sp>
-      <p:sp>
-        <p:nvSpPr>
           <p:cNvPr id="6" name="Text 4"/>
           <p:cNvSpPr/>
           <p:nvPr/>
         </p:nvSpPr>
         <p:spPr>
           <a:xfrm>
-            <a:off x="457200" y="2240280"/>
-            <a:ext cx="10972800" cy="822960"/>
-          </a:xfrm>
-          <a:prstGeom prst="rect">
-            <a:avLst/>
-          </a:prstGeom>
-          <a:noFill/>
-          <a:ln/>
-        </p:spPr>
-        <p:txBody>
-          <a:bodyPr wrap="square" rtlCol="0" anchor="t"/>
+            <a:off x="457200" y="2767584"/>
+            <a:ext cx="6949440" cy="502920"/>
+          </a:xfrm>
+          <a:prstGeom prst="rect">
+            <a:avLst/>
+          </a:prstGeom>
+          <a:noFill/>
+          <a:ln/>
+        </p:spPr>
+        <p:txBody>
+          <a:bodyPr wrap="square" rtlCol="0" anchor="t">
+            <a:normAutofit/>
+          </a:bodyPr>
           <a:lstStyle/>
           <a:p>
             <a:pPr indent="0" marL="0">
@@ -2154,8 +2160,8 @@
         </p:blipFill>
         <p:spPr>
           <a:xfrm>
-            <a:off x="7772400" y="1097280"/>
-            <a:ext cx="3657600" cy="2286000"/>
+            <a:off x="7680960" y="1005840"/>
+            <a:ext cx="3840480" cy="2560320"/>
           </a:xfrm>
           <a:prstGeom prst="rect">
             <a:avLst/>
@@ -2272,6 +2278,88 @@
           </a:p>
         </p:txBody>
       </p:sp>
+      <p:sp>
+        <p:nvSpPr>
+          <p:cNvPr id="4" name="Text 2"/>
+          <p:cNvSpPr/>
+          <p:nvPr/>
+        </p:nvSpPr>
+        <p:spPr>
+          <a:xfrm>
+            <a:off x="457200" y="868680"/>
+            <a:ext cx="10972800" cy="502920"/>
+          </a:xfrm>
+          <a:prstGeom prst="rect">
+            <a:avLst/>
+          </a:prstGeom>
+          <a:noFill/>
+          <a:ln/>
+        </p:spPr>
+        <p:txBody>
+          <a:bodyPr wrap="square" rtlCol="0" anchor="t">
+            <a:normAutofit/>
+          </a:bodyPr>
+          <a:lstStyle/>
+          <a:p>
+            <a:pPr indent="0" marL="0">
+              <a:buNone/>
+            </a:pPr>
+            <a:r>
+              <a:rPr lang="en-US" sz="2200" b="1" dirty="0">
+                <a:solidFill>
+                  <a:srgbClr val="1A1A1A"/>
+                </a:solidFill>
+                <a:latin typeface="Arial" pitchFamily="34" charset="0"/>
+                <a:ea typeface="Arial" pitchFamily="34" charset="-122"/>
+                <a:cs typeface="Arial" pitchFamily="34" charset="-120"/>
+              </a:rPr>
+              <a:t>Umgang mit Einwänden</a:t>
+            </a:r>
+            <a:endParaRPr lang="en-US" sz="2200" dirty="0"/>
+          </a:p>
+        </p:txBody>
+      </p:sp>
+      <p:sp>
+        <p:nvSpPr>
+          <p:cNvPr id="5" name="Text 3"/>
+          <p:cNvSpPr/>
+          <p:nvPr/>
+        </p:nvSpPr>
+        <p:spPr>
+          <a:xfrm>
+            <a:off x="457200" y="1481328"/>
+            <a:ext cx="10972800" cy="502920"/>
+          </a:xfrm>
+          <a:prstGeom prst="rect">
+            <a:avLst/>
+          </a:prstGeom>
+          <a:noFill/>
+          <a:ln/>
+        </p:spPr>
+        <p:txBody>
+          <a:bodyPr wrap="square" rtlCol="0" anchor="t">
+            <a:normAutofit/>
+          </a:bodyPr>
+          <a:lstStyle/>
+          <a:p>
+            <a:pPr indent="0" marL="0">
+              <a:buNone/>
+            </a:pPr>
+            <a:r>
+              <a:rPr lang="en-US" sz="2200" b="1" dirty="0">
+                <a:solidFill>
+                  <a:srgbClr val="1A1A1A"/>
+                </a:solidFill>
+                <a:latin typeface="Arial" pitchFamily="34" charset="0"/>
+                <a:ea typeface="Arial" pitchFamily="34" charset="-122"/>
+                <a:cs typeface="Arial" pitchFamily="34" charset="-120"/>
+              </a:rPr>
+              <a:t>Die fünf häufigsten Bedenken — und wie man sie beantwortet.</a:t>
+            </a:r>
+            <a:endParaRPr lang="en-US" sz="2200" dirty="0"/>
+          </a:p>
+        </p:txBody>
+      </p:sp>
     </p:spTree>
   </p:cSld>
   <p:clrMapOvr>
@@ -2382,6 +2470,334 @@
           </a:p>
         </p:txBody>
       </p:sp>
+      <p:sp>
+        <p:nvSpPr>
+          <p:cNvPr id="4" name="Text 2"/>
+          <p:cNvSpPr/>
+          <p:nvPr/>
+        </p:nvSpPr>
+        <p:spPr>
+          <a:xfrm>
+            <a:off x="457200" y="868680"/>
+            <a:ext cx="10972800" cy="502920"/>
+          </a:xfrm>
+          <a:prstGeom prst="rect">
+            <a:avLst/>
+          </a:prstGeom>
+          <a:noFill/>
+          <a:ln/>
+        </p:spPr>
+        <p:txBody>
+          <a:bodyPr wrap="square" rtlCol="0" anchor="t">
+            <a:normAutofit/>
+          </a:bodyPr>
+          <a:lstStyle/>
+          <a:p>
+            <a:pPr indent="0" marL="0">
+              <a:buNone/>
+            </a:pPr>
+            <a:r>
+              <a:rPr lang="en-US" sz="2200" b="1" dirty="0">
+                <a:solidFill>
+                  <a:srgbClr val="1A1A1A"/>
+                </a:solidFill>
+                <a:latin typeface="Arial" pitchFamily="34" charset="0"/>
+                <a:ea typeface="Arial" pitchFamily="34" charset="-122"/>
+                <a:cs typeface="Arial" pitchFamily="34" charset="-120"/>
+              </a:rPr>
+              <a:t>Wettbewerbspositionierung</a:t>
+            </a:r>
+            <a:endParaRPr lang="en-US" sz="2200" dirty="0"/>
+          </a:p>
+        </p:txBody>
+      </p:sp>
+      <p:sp>
+        <p:nvSpPr>
+          <p:cNvPr id="5" name="Text 3"/>
+          <p:cNvSpPr/>
+          <p:nvPr/>
+        </p:nvSpPr>
+        <p:spPr>
+          <a:xfrm>
+            <a:off x="457200" y="1481328"/>
+            <a:ext cx="10972800" cy="502920"/>
+          </a:xfrm>
+          <a:prstGeom prst="rect">
+            <a:avLst/>
+          </a:prstGeom>
+          <a:noFill/>
+          <a:ln/>
+        </p:spPr>
+        <p:txBody>
+          <a:bodyPr wrap="square" rtlCol="0" anchor="t">
+            <a:normAutofit/>
+          </a:bodyPr>
+          <a:lstStyle/>
+          <a:p>
+            <a:pPr indent="0" marL="0">
+              <a:buNone/>
+            </a:pPr>
+            <a:r>
+              <a:rPr lang="en-US" sz="2200" b="1" dirty="0">
+                <a:solidFill>
+                  <a:srgbClr val="1A1A1A"/>
+                </a:solidFill>
+                <a:latin typeface="Arial" pitchFamily="34" charset="0"/>
+                <a:ea typeface="Arial" pitchFamily="34" charset="-122"/>
+                <a:cs typeface="Arial" pitchFamily="34" charset="-120"/>
+              </a:rPr>
+              <a:t>Warum wir gewinnen.</a:t>
+            </a:r>
+            <a:endParaRPr lang="en-US" sz="2200" dirty="0"/>
+          </a:p>
+        </p:txBody>
+      </p:sp>
+      <p:sp>
+        <p:nvSpPr>
+          <p:cNvPr id="6" name="Text 4"/>
+          <p:cNvSpPr/>
+          <p:nvPr/>
+        </p:nvSpPr>
+        <p:spPr>
+          <a:xfrm>
+            <a:off x="457200" y="2093976"/>
+            <a:ext cx="10972800" cy="502920"/>
+          </a:xfrm>
+          <a:prstGeom prst="rect">
+            <a:avLst/>
+          </a:prstGeom>
+          <a:noFill/>
+          <a:ln/>
+        </p:spPr>
+        <p:txBody>
+          <a:bodyPr wrap="square" rtlCol="0" anchor="t">
+            <a:normAutofit/>
+          </a:bodyPr>
+          <a:lstStyle/>
+          <a:p>
+            <a:pPr indent="0" marL="0">
+              <a:buNone/>
+            </a:pPr>
+            <a:r>
+              <a:rPr lang="en-US" sz="1300" dirty="0">
+                <a:solidFill>
+                  <a:srgbClr val="4A4A4A"/>
+                </a:solidFill>
+                <a:latin typeface="Arial" pitchFamily="34" charset="0"/>
+                <a:ea typeface="Arial" pitchFamily="34" charset="-122"/>
+                <a:cs typeface="Arial" pitchFamily="34" charset="-120"/>
+              </a:rPr>
+              <a:t>Vier Kategorien. Ein Satz pro Kategorie. Verwenden Sie die passende Zeile, wenn ein Interessent einen bestimmten Wettbewerber nennt.</a:t>
+            </a:r>
+            <a:endParaRPr lang="en-US" sz="1300" dirty="0"/>
+          </a:p>
+        </p:txBody>
+      </p:sp>
+      <p:sp>
+        <p:nvSpPr>
+          <p:cNvPr id="7" name="Text 5"/>
+          <p:cNvSpPr/>
+          <p:nvPr/>
+        </p:nvSpPr>
+        <p:spPr>
+          <a:xfrm>
+            <a:off x="457200" y="2734056"/>
+            <a:ext cx="10972800" cy="502920"/>
+          </a:xfrm>
+          <a:prstGeom prst="rect">
+            <a:avLst/>
+          </a:prstGeom>
+          <a:noFill/>
+          <a:ln/>
+        </p:spPr>
+        <p:txBody>
+          <a:bodyPr wrap="square" rtlCol="0" anchor="t">
+            <a:normAutofit/>
+          </a:bodyPr>
+          <a:lstStyle/>
+          <a:p>
+            <a:pPr indent="0" marL="0">
+              <a:buNone/>
+            </a:pPr>
+            <a:r>
+              <a:rPr lang="en-US" sz="1600" b="1" dirty="0">
+                <a:solidFill>
+                  <a:srgbClr val="1A1A1A"/>
+                </a:solidFill>
+                <a:latin typeface="Arial" pitchFamily="34" charset="0"/>
+                <a:ea typeface="Arial" pitchFamily="34" charset="-122"/>
+                <a:cs typeface="Arial" pitchFamily="34" charset="-120"/>
+              </a:rPr>
+              <a:t>Kernaussage</a:t>
+            </a:r>
+            <a:endParaRPr lang="en-US" sz="1600" dirty="0"/>
+          </a:p>
+        </p:txBody>
+      </p:sp>
+      <p:sp>
+        <p:nvSpPr>
+          <p:cNvPr id="8" name="Text 6"/>
+          <p:cNvSpPr/>
+          <p:nvPr/>
+        </p:nvSpPr>
+        <p:spPr>
+          <a:xfrm>
+            <a:off x="457200" y="3346704"/>
+            <a:ext cx="10972800" cy="502920"/>
+          </a:xfrm>
+          <a:prstGeom prst="rect">
+            <a:avLst/>
+          </a:prstGeom>
+          <a:noFill/>
+          <a:ln/>
+        </p:spPr>
+        <p:txBody>
+          <a:bodyPr wrap="square" rtlCol="0" anchor="t">
+            <a:normAutofit/>
+          </a:bodyPr>
+          <a:lstStyle/>
+          <a:p>
+            <a:pPr indent="0" marL="0">
+              <a:buNone/>
+            </a:pPr>
+            <a:r>
+              <a:rPr lang="en-US" sz="1300" dirty="0">
+                <a:solidFill>
+                  <a:srgbClr val="4A4A4A"/>
+                </a:solidFill>
+                <a:latin typeface="Arial" pitchFamily="34" charset="0"/>
+                <a:ea typeface="Arial" pitchFamily="34" charset="-122"/>
+                <a:cs typeface="Arial" pitchFamily="34" charset="-120"/>
+              </a:rPr>
+              <a:t>Von Menschen entworfene Originalität, vollständige Rechtsübertragung, 11 Dateiformate. Kostenlose Tools bieten meist begrenzte Originalität, Teilrechte und weniger Formate.</a:t>
+            </a:r>
+            <a:endParaRPr lang="en-US" sz="1300" dirty="0"/>
+          </a:p>
+        </p:txBody>
+      </p:sp>
+      <p:sp>
+        <p:nvSpPr>
+          <p:cNvPr id="9" name="Text 7"/>
+          <p:cNvSpPr/>
+          <p:nvPr/>
+        </p:nvSpPr>
+        <p:spPr>
+          <a:xfrm>
+            <a:off x="457200" y="3986784"/>
+            <a:ext cx="10972800" cy="502920"/>
+          </a:xfrm>
+          <a:prstGeom prst="rect">
+            <a:avLst/>
+          </a:prstGeom>
+          <a:noFill/>
+          <a:ln/>
+        </p:spPr>
+        <p:txBody>
+          <a:bodyPr wrap="square" rtlCol="0" anchor="t">
+            <a:normAutofit/>
+          </a:bodyPr>
+          <a:lstStyle/>
+          <a:p>
+            <a:pPr indent="0" marL="0">
+              <a:buNone/>
+            </a:pPr>
+            <a:r>
+              <a:rPr lang="en-US" sz="1300" dirty="0">
+                <a:solidFill>
+                  <a:srgbClr val="4A4A4A"/>
+                </a:solidFill>
+                <a:latin typeface="Arial" pitchFamily="34" charset="0"/>
+                <a:ea typeface="Arial" pitchFamily="34" charset="-122"/>
+                <a:cs typeface="Arial" pitchFamily="34" charset="-120"/>
+              </a:rPr>
+              <a:t>Ein dedizierter Koordinator und ein hausinternes Team mit über 75.000 gelieferten Logos — kein Fremder mit dreißig parallelen Projekten. Berechenbare Bearbeitungszeiten.</a:t>
+            </a:r>
+            <a:endParaRPr lang="en-US" sz="1300" dirty="0"/>
+          </a:p>
+        </p:txBody>
+      </p:sp>
+      <p:sp>
+        <p:nvSpPr>
+          <p:cNvPr id="10" name="Text 8"/>
+          <p:cNvSpPr/>
+          <p:nvPr/>
+        </p:nvSpPr>
+        <p:spPr>
+          <a:xfrm>
+            <a:off x="457200" y="4626864"/>
+            <a:ext cx="10972800" cy="502920"/>
+          </a:xfrm>
+          <a:prstGeom prst="rect">
+            <a:avLst/>
+          </a:prstGeom>
+          <a:noFill/>
+          <a:ln/>
+        </p:spPr>
+        <p:txBody>
+          <a:bodyPr wrap="square" rtlCol="0" anchor="t">
+            <a:normAutofit/>
+          </a:bodyPr>
+          <a:lstStyle/>
+          <a:p>
+            <a:pPr indent="0" marL="0">
+              <a:buNone/>
+            </a:pPr>
+            <a:r>
+              <a:rPr lang="en-US" sz="1300" dirty="0">
+                <a:solidFill>
+                  <a:srgbClr val="4A4A4A"/>
+                </a:solidFill>
+                <a:latin typeface="Arial" pitchFamily="34" charset="0"/>
+                <a:ea typeface="Arial" pitchFamily="34" charset="-122"/>
+                <a:cs typeface="Arial" pitchFamily="34" charset="-120"/>
+              </a:rPr>
+              <a:t>Vergleichbare Qualität zu einem Bruchteil der Kosten, mit definiertem Umfang und Zeitplan. Keine Überraschungsrechnungen, kein Scope-Creep, keine sechsmonatigen Engagements.</a:t>
+            </a:r>
+            <a:endParaRPr lang="en-US" sz="1300" dirty="0"/>
+          </a:p>
+        </p:txBody>
+      </p:sp>
+      <p:sp>
+        <p:nvSpPr>
+          <p:cNvPr id="11" name="Text 9"/>
+          <p:cNvSpPr/>
+          <p:nvPr/>
+        </p:nvSpPr>
+        <p:spPr>
+          <a:xfrm>
+            <a:off x="457200" y="5266944"/>
+            <a:ext cx="10972800" cy="502920"/>
+          </a:xfrm>
+          <a:prstGeom prst="rect">
+            <a:avLst/>
+          </a:prstGeom>
+          <a:noFill/>
+          <a:ln/>
+        </p:spPr>
+        <p:txBody>
+          <a:bodyPr wrap="square" rtlCol="0" anchor="t">
+            <a:normAutofit/>
+          </a:bodyPr>
+          <a:lstStyle/>
+          <a:p>
+            <a:pPr indent="0" marL="0">
+              <a:buNone/>
+            </a:pPr>
+            <a:r>
+              <a:rPr lang="en-US" sz="1300" dirty="0">
+                <a:solidFill>
+                  <a:srgbClr val="4A4A4A"/>
+                </a:solidFill>
+                <a:latin typeface="Arial" pitchFamily="34" charset="0"/>
+                <a:ea typeface="Arial" pitchFamily="34" charset="-122"/>
+                <a:cs typeface="Arial" pitchFamily="34" charset="-120"/>
+              </a:rPr>
+              <a:t>20% der Logos von 2025 sind KI-generiert — sie ähneln sich zunehmend. Von Menschen gestaltete Marken bleiben differenzierter — und besser als Marke schützbar.</a:t>
+            </a:r>
+            <a:endParaRPr lang="en-US" sz="1300" dirty="0"/>
+          </a:p>
+        </p:txBody>
+      </p:sp>
     </p:spTree>
   </p:cSld>
   <p:clrMapOvr>
@@ -2492,6 +2908,375 @@
           </a:p>
         </p:txBody>
       </p:sp>
+      <p:sp>
+        <p:nvSpPr>
+          <p:cNvPr id="4" name="Text 2"/>
+          <p:cNvSpPr/>
+          <p:nvPr/>
+        </p:nvSpPr>
+        <p:spPr>
+          <a:xfrm>
+            <a:off x="457200" y="868680"/>
+            <a:ext cx="10972800" cy="502920"/>
+          </a:xfrm>
+          <a:prstGeom prst="rect">
+            <a:avLst/>
+          </a:prstGeom>
+          <a:noFill/>
+          <a:ln/>
+        </p:spPr>
+        <p:txBody>
+          <a:bodyPr wrap="square" rtlCol="0" anchor="t">
+            <a:normAutofit/>
+          </a:bodyPr>
+          <a:lstStyle/>
+          <a:p>
+            <a:pPr indent="0" marL="0">
+              <a:buNone/>
+            </a:pPr>
+            <a:r>
+              <a:rPr lang="en-US" sz="2200" b="1" dirty="0">
+                <a:solidFill>
+                  <a:srgbClr val="1A1A1A"/>
+                </a:solidFill>
+                <a:latin typeface="Arial" pitchFamily="34" charset="0"/>
+                <a:ea typeface="Arial" pitchFamily="34" charset="-122"/>
+                <a:cs typeface="Arial" pitchFamily="34" charset="-120"/>
+              </a:rPr>
+              <a:t>Häufige Fragen</a:t>
+            </a:r>
+            <a:endParaRPr lang="en-US" sz="2200" dirty="0"/>
+          </a:p>
+        </p:txBody>
+      </p:sp>
+      <p:sp>
+        <p:nvSpPr>
+          <p:cNvPr id="5" name="Text 3"/>
+          <p:cNvSpPr/>
+          <p:nvPr/>
+        </p:nvSpPr>
+        <p:spPr>
+          <a:xfrm>
+            <a:off x="457200" y="1481328"/>
+            <a:ext cx="10972800" cy="502920"/>
+          </a:xfrm>
+          <a:prstGeom prst="rect">
+            <a:avLst/>
+          </a:prstGeom>
+          <a:noFill/>
+          <a:ln/>
+        </p:spPr>
+        <p:txBody>
+          <a:bodyPr wrap="square" rtlCol="0" anchor="t">
+            <a:normAutofit/>
+          </a:bodyPr>
+          <a:lstStyle/>
+          <a:p>
+            <a:pPr indent="0" marL="0">
+              <a:buNone/>
+            </a:pPr>
+            <a:r>
+              <a:rPr lang="en-US" sz="2200" b="1" dirty="0">
+                <a:solidFill>
+                  <a:srgbClr val="1A1A1A"/>
+                </a:solidFill>
+                <a:latin typeface="Arial" pitchFamily="34" charset="0"/>
+                <a:ea typeface="Arial" pitchFamily="34" charset="-122"/>
+                <a:cs typeface="Arial" pitchFamily="34" charset="-120"/>
+              </a:rPr>
+              <a:t>Die häufigsten Kundenfragen.</a:t>
+            </a:r>
+            <a:endParaRPr lang="en-US" sz="2200" dirty="0"/>
+          </a:p>
+        </p:txBody>
+      </p:sp>
+      <p:sp>
+        <p:nvSpPr>
+          <p:cNvPr id="6" name="Text 4"/>
+          <p:cNvSpPr/>
+          <p:nvPr/>
+        </p:nvSpPr>
+        <p:spPr>
+          <a:xfrm>
+            <a:off x="457200" y="2093976"/>
+            <a:ext cx="10972800" cy="502920"/>
+          </a:xfrm>
+          <a:prstGeom prst="rect">
+            <a:avLst/>
+          </a:prstGeom>
+          <a:noFill/>
+          <a:ln/>
+        </p:spPr>
+        <p:txBody>
+          <a:bodyPr wrap="square" rtlCol="0" anchor="t">
+            <a:normAutofit/>
+          </a:bodyPr>
+          <a:lstStyle/>
+          <a:p>
+            <a:pPr indent="0" marL="0">
+              <a:buNone/>
+            </a:pPr>
+            <a:r>
+              <a:rPr lang="en-US" sz="1600" b="1" dirty="0">
+                <a:solidFill>
+                  <a:srgbClr val="1A1A1A"/>
+                </a:solidFill>
+                <a:latin typeface="Arial" pitchFamily="34" charset="0"/>
+                <a:ea typeface="Arial" pitchFamily="34" charset="-122"/>
+                <a:cs typeface="Arial" pitchFamily="34" charset="-120"/>
+              </a:rPr>
+              <a:t>Wie viele Revisionen sind enthalten?</a:t>
+            </a:r>
+            <a:endParaRPr lang="en-US" sz="1600" dirty="0"/>
+          </a:p>
+        </p:txBody>
+      </p:sp>
+      <p:sp>
+        <p:nvSpPr>
+          <p:cNvPr id="7" name="Text 5"/>
+          <p:cNvSpPr/>
+          <p:nvPr/>
+        </p:nvSpPr>
+        <p:spPr>
+          <a:xfrm>
+            <a:off x="457200" y="2706624"/>
+            <a:ext cx="10972800" cy="502920"/>
+          </a:xfrm>
+          <a:prstGeom prst="rect">
+            <a:avLst/>
+          </a:prstGeom>
+          <a:noFill/>
+          <a:ln/>
+        </p:spPr>
+        <p:txBody>
+          <a:bodyPr wrap="square" rtlCol="0" anchor="t">
+            <a:normAutofit/>
+          </a:bodyPr>
+          <a:lstStyle/>
+          <a:p>
+            <a:pPr indent="0" marL="0">
+              <a:buNone/>
+            </a:pPr>
+            <a:r>
+              <a:rPr lang="en-US" sz="1300" dirty="0">
+                <a:solidFill>
+                  <a:srgbClr val="4A4A4A"/>
+                </a:solidFill>
+                <a:latin typeface="Arial" pitchFamily="34" charset="0"/>
+                <a:ea typeface="Arial" pitchFamily="34" charset="-122"/>
+                <a:cs typeface="Arial" pitchFamily="34" charset="-120"/>
+              </a:rPr>
+              <a:t>Bis zu drei Runden in jedem Paket. Zusätzliche Revisionen sind gegen Aufpreis verfügbar.</a:t>
+            </a:r>
+            <a:endParaRPr lang="en-US" sz="1300" dirty="0"/>
+          </a:p>
+        </p:txBody>
+      </p:sp>
+      <p:sp>
+        <p:nvSpPr>
+          <p:cNvPr id="8" name="Text 6"/>
+          <p:cNvSpPr/>
+          <p:nvPr/>
+        </p:nvSpPr>
+        <p:spPr>
+          <a:xfrm>
+            <a:off x="457200" y="3346704"/>
+            <a:ext cx="10972800" cy="502920"/>
+          </a:xfrm>
+          <a:prstGeom prst="rect">
+            <a:avLst/>
+          </a:prstGeom>
+          <a:noFill/>
+          <a:ln/>
+        </p:spPr>
+        <p:txBody>
+          <a:bodyPr wrap="square" rtlCol="0" anchor="t">
+            <a:normAutofit/>
+          </a:bodyPr>
+          <a:lstStyle/>
+          <a:p>
+            <a:pPr indent="0" marL="0">
+              <a:buNone/>
+            </a:pPr>
+            <a:r>
+              <a:rPr lang="en-US" sz="1600" b="1" dirty="0">
+                <a:solidFill>
+                  <a:srgbClr val="1A1A1A"/>
+                </a:solidFill>
+                <a:latin typeface="Arial" pitchFamily="34" charset="0"/>
+                <a:ea typeface="Arial" pitchFamily="34" charset="-122"/>
+                <a:cs typeface="Arial" pitchFamily="34" charset="-120"/>
+              </a:rPr>
+              <a:t>Wie lange dauert es?</a:t>
+            </a:r>
+            <a:endParaRPr lang="en-US" sz="1600" dirty="0"/>
+          </a:p>
+        </p:txBody>
+      </p:sp>
+      <p:sp>
+        <p:nvSpPr>
+          <p:cNvPr id="9" name="Text 7"/>
+          <p:cNvSpPr/>
+          <p:nvPr/>
+        </p:nvSpPr>
+        <p:spPr>
+          <a:xfrm>
+            <a:off x="457200" y="3959352"/>
+            <a:ext cx="10972800" cy="502920"/>
+          </a:xfrm>
+          <a:prstGeom prst="rect">
+            <a:avLst/>
+          </a:prstGeom>
+          <a:noFill/>
+          <a:ln/>
+        </p:spPr>
+        <p:txBody>
+          <a:bodyPr wrap="square" rtlCol="0" anchor="t">
+            <a:normAutofit/>
+          </a:bodyPr>
+          <a:lstStyle/>
+          <a:p>
+            <a:pPr indent="0" marL="0">
+              <a:buNone/>
+            </a:pPr>
+            <a:r>
+              <a:rPr lang="en-US" sz="1300" dirty="0">
+                <a:solidFill>
+                  <a:srgbClr val="4A4A4A"/>
+                </a:solidFill>
+                <a:latin typeface="Arial" pitchFamily="34" charset="0"/>
+                <a:ea typeface="Arial" pitchFamily="34" charset="-122"/>
+                <a:cs typeface="Arial" pitchFamily="34" charset="-120"/>
+              </a:rPr>
+              <a:t>Konzepte kommen in drei bis fünf Werktagen. Komplette Projekte werden meist in zwei bis drei Wochen abgeschlossen.</a:t>
+            </a:r>
+            <a:endParaRPr lang="en-US" sz="1300" dirty="0"/>
+          </a:p>
+        </p:txBody>
+      </p:sp>
+      <p:sp>
+        <p:nvSpPr>
+          <p:cNvPr id="10" name="Text 8"/>
+          <p:cNvSpPr/>
+          <p:nvPr/>
+        </p:nvSpPr>
+        <p:spPr>
+          <a:xfrm>
+            <a:off x="457200" y="4599432"/>
+            <a:ext cx="10972800" cy="502920"/>
+          </a:xfrm>
+          <a:prstGeom prst="rect">
+            <a:avLst/>
+          </a:prstGeom>
+          <a:noFill/>
+          <a:ln/>
+        </p:spPr>
+        <p:txBody>
+          <a:bodyPr wrap="square" rtlCol="0" anchor="t">
+            <a:normAutofit/>
+          </a:bodyPr>
+          <a:lstStyle/>
+          <a:p>
+            <a:pPr indent="0" marL="0">
+              <a:buNone/>
+            </a:pPr>
+            <a:r>
+              <a:rPr lang="en-US" sz="1600" b="1" dirty="0">
+                <a:solidFill>
+                  <a:srgbClr val="1A1A1A"/>
+                </a:solidFill>
+                <a:latin typeface="Arial" pitchFamily="34" charset="0"/>
+                <a:ea typeface="Arial" pitchFamily="34" charset="-122"/>
+                <a:cs typeface="Arial" pitchFamily="34" charset="-120"/>
+              </a:rPr>
+              <a:t>Welche Dateiformate erhalte ich?</a:t>
+            </a:r>
+            <a:endParaRPr lang="en-US" sz="1600" dirty="0"/>
+          </a:p>
+        </p:txBody>
+      </p:sp>
+      <p:sp>
+        <p:nvSpPr>
+          <p:cNvPr id="11" name="Text 9"/>
+          <p:cNvSpPr/>
+          <p:nvPr/>
+        </p:nvSpPr>
+        <p:spPr>
+          <a:xfrm>
+            <a:off x="457200" y="5212080"/>
+            <a:ext cx="10972800" cy="502920"/>
+          </a:xfrm>
+          <a:prstGeom prst="rect">
+            <a:avLst/>
+          </a:prstGeom>
+          <a:noFill/>
+          <a:ln/>
+        </p:spPr>
+        <p:txBody>
+          <a:bodyPr wrap="square" rtlCol="0" anchor="t">
+            <a:normAutofit/>
+          </a:bodyPr>
+          <a:lstStyle/>
+          <a:p>
+            <a:pPr indent="0" marL="0">
+              <a:buNone/>
+            </a:pPr>
+            <a:r>
+              <a:rPr lang="en-US" sz="1300" dirty="0">
+                <a:solidFill>
+                  <a:srgbClr val="4A4A4A"/>
+                </a:solidFill>
+                <a:latin typeface="Arial" pitchFamily="34" charset="0"/>
+                <a:ea typeface="Arial" pitchFamily="34" charset="-122"/>
+                <a:cs typeface="Arial" pitchFamily="34" charset="-120"/>
+              </a:rPr>
+              <a:t>Elf Formate — AI, EPS, PDF, JPG, PNG, GIF und ICO. Sechs in Farbe, fünf in Schwarz-Weiß.</a:t>
+            </a:r>
+            <a:endParaRPr lang="en-US" sz="1300" dirty="0"/>
+          </a:p>
+        </p:txBody>
+      </p:sp>
+      <p:sp>
+        <p:nvSpPr>
+          <p:cNvPr id="12" name="Text 10"/>
+          <p:cNvSpPr/>
+          <p:nvPr/>
+        </p:nvSpPr>
+        <p:spPr>
+          <a:xfrm>
+            <a:off x="457200" y="5852160"/>
+            <a:ext cx="10972800" cy="502920"/>
+          </a:xfrm>
+          <a:prstGeom prst="rect">
+            <a:avLst/>
+          </a:prstGeom>
+          <a:noFill/>
+          <a:ln/>
+        </p:spPr>
+        <p:txBody>
+          <a:bodyPr wrap="square" rtlCol="0" anchor="t">
+            <a:normAutofit/>
+          </a:bodyPr>
+          <a:lstStyle/>
+          <a:p>
+            <a:pPr indent="0" marL="0">
+              <a:buNone/>
+            </a:pPr>
+            <a:r>
+              <a:rPr lang="en-US" sz="1600" b="1" dirty="0">
+                <a:solidFill>
+                  <a:srgbClr val="1A1A1A"/>
+                </a:solidFill>
+                <a:latin typeface="Arial" pitchFamily="34" charset="0"/>
+                <a:ea typeface="Arial" pitchFamily="34" charset="-122"/>
+                <a:cs typeface="Arial" pitchFamily="34" charset="-120"/>
+              </a:rPr>
+              <a:t>Wem gehört das fertige Logo?</a:t>
+            </a:r>
+            <a:endParaRPr lang="en-US" sz="1600" dirty="0"/>
+          </a:p>
+        </p:txBody>
+      </p:sp>
     </p:spTree>
   </p:cSld>
   <p:clrMapOvr>
@@ -2602,6 +3387,129 @@
           </a:p>
         </p:txBody>
       </p:sp>
+      <p:sp>
+        <p:nvSpPr>
+          <p:cNvPr id="4" name="Text 2"/>
+          <p:cNvSpPr/>
+          <p:nvPr/>
+        </p:nvSpPr>
+        <p:spPr>
+          <a:xfrm>
+            <a:off x="457200" y="868680"/>
+            <a:ext cx="10972800" cy="502920"/>
+          </a:xfrm>
+          <a:prstGeom prst="rect">
+            <a:avLst/>
+          </a:prstGeom>
+          <a:noFill/>
+          <a:ln/>
+        </p:spPr>
+        <p:txBody>
+          <a:bodyPr wrap="square" rtlCol="0" anchor="t">
+            <a:normAutofit/>
+          </a:bodyPr>
+          <a:lstStyle/>
+          <a:p>
+            <a:pPr indent="0" marL="0">
+              <a:buNone/>
+            </a:pPr>
+            <a:r>
+              <a:rPr lang="en-US" sz="2800" b="1" dirty="0">
+                <a:solidFill>
+                  <a:srgbClr val="1A1A1A"/>
+                </a:solidFill>
+                <a:latin typeface="Arial" pitchFamily="34" charset="0"/>
+                <a:ea typeface="Arial" pitchFamily="34" charset="-122"/>
+                <a:cs typeface="Arial" pitchFamily="34" charset="-120"/>
+              </a:rPr>
+              <a:t>Loslegen</a:t>
+            </a:r>
+            <a:endParaRPr lang="en-US" sz="2800" dirty="0"/>
+          </a:p>
+        </p:txBody>
+      </p:sp>
+      <p:sp>
+        <p:nvSpPr>
+          <p:cNvPr id="5" name="Text 3"/>
+          <p:cNvSpPr/>
+          <p:nvPr/>
+        </p:nvSpPr>
+        <p:spPr>
+          <a:xfrm>
+            <a:off x="457200" y="1481328"/>
+            <a:ext cx="10972800" cy="502920"/>
+          </a:xfrm>
+          <a:prstGeom prst="rect">
+            <a:avLst/>
+          </a:prstGeom>
+          <a:noFill/>
+          <a:ln/>
+        </p:spPr>
+        <p:txBody>
+          <a:bodyPr wrap="square" rtlCol="0" anchor="t">
+            <a:normAutofit/>
+          </a:bodyPr>
+          <a:lstStyle/>
+          <a:p>
+            <a:pPr indent="0" marL="0">
+              <a:buNone/>
+            </a:pPr>
+            <a:r>
+              <a:rPr lang="en-US" sz="1300" dirty="0">
+                <a:solidFill>
+                  <a:srgbClr val="4A4A4A"/>
+                </a:solidFill>
+                <a:latin typeface="Arial" pitchFamily="34" charset="0"/>
+                <a:ea typeface="Arial" pitchFamily="34" charset="-122"/>
+                <a:cs typeface="Arial" pitchFamily="34" charset="-120"/>
+              </a:rPr>
+              <a:t>Haben Sie Fragen, möchten Sie eine Demo vereinbaren oder erfahren, wie diese Lösungen Ihre Vertriebsteams heute unterstützen können?</a:t>
+            </a:r>
+            <a:endParaRPr lang="en-US" sz="1300" dirty="0"/>
+          </a:p>
+        </p:txBody>
+      </p:sp>
+      <p:sp>
+        <p:nvSpPr>
+          <p:cNvPr id="6" name="Text 4"/>
+          <p:cNvSpPr/>
+          <p:nvPr/>
+        </p:nvSpPr>
+        <p:spPr>
+          <a:xfrm>
+            <a:off x="457200" y="2121408"/>
+            <a:ext cx="10972800" cy="502920"/>
+          </a:xfrm>
+          <a:prstGeom prst="rect">
+            <a:avLst/>
+          </a:prstGeom>
+          <a:noFill/>
+          <a:ln/>
+        </p:spPr>
+        <p:txBody>
+          <a:bodyPr wrap="square" rtlCol="0" anchor="t">
+            <a:normAutofit/>
+          </a:bodyPr>
+          <a:lstStyle/>
+          <a:p>
+            <a:pPr indent="0" marL="0">
+              <a:buNone/>
+            </a:pPr>
+            <a:r>
+              <a:rPr lang="en-US" sz="1300" dirty="0">
+                <a:solidFill>
+                  <a:srgbClr val="4A4A4A"/>
+                </a:solidFill>
+                <a:latin typeface="Arial" pitchFamily="34" charset="0"/>
+                <a:ea typeface="Arial" pitchFamily="34" charset="-122"/>
+                <a:cs typeface="Arial" pitchFamily="34" charset="-120"/>
+              </a:rPr>
+              <a:t>Kontaktieren Sie uns unter marketing@hostopia.com, um mehr zu erfahren und mit einem unserer Experten in Kontakt zu treten.</a:t>
+            </a:r>
+            <a:endParaRPr lang="en-US" sz="1300" dirty="0"/>
+          </a:p>
+        </p:txBody>
+      </p:sp>
     </p:spTree>
   </p:cSld>
   <p:clrMapOvr>
@@ -2712,6 +3620,375 @@
           </a:p>
         </p:txBody>
       </p:sp>
+      <p:sp>
+        <p:nvSpPr>
+          <p:cNvPr id="4" name="Text 2"/>
+          <p:cNvSpPr/>
+          <p:nvPr/>
+        </p:nvSpPr>
+        <p:spPr>
+          <a:xfrm>
+            <a:off x="457200" y="868680"/>
+            <a:ext cx="10972800" cy="502920"/>
+          </a:xfrm>
+          <a:prstGeom prst="rect">
+            <a:avLst/>
+          </a:prstGeom>
+          <a:noFill/>
+          <a:ln/>
+        </p:spPr>
+        <p:txBody>
+          <a:bodyPr wrap="square" rtlCol="0" anchor="t">
+            <a:normAutofit/>
+          </a:bodyPr>
+          <a:lstStyle/>
+          <a:p>
+            <a:pPr indent="0" marL="0">
+              <a:buNone/>
+            </a:pPr>
+            <a:r>
+              <a:rPr lang="en-US" sz="2200" b="1" dirty="0">
+                <a:solidFill>
+                  <a:srgbClr val="1A1A1A"/>
+                </a:solidFill>
+                <a:latin typeface="Arial" pitchFamily="34" charset="0"/>
+                <a:ea typeface="Arial" pitchFamily="34" charset="-122"/>
+                <a:cs typeface="Arial" pitchFamily="34" charset="-120"/>
+              </a:rPr>
+              <a:t>Was wir behandeln werden.</a:t>
+            </a:r>
+            <a:endParaRPr lang="en-US" sz="2200" dirty="0"/>
+          </a:p>
+        </p:txBody>
+      </p:sp>
+      <p:sp>
+        <p:nvSpPr>
+          <p:cNvPr id="5" name="Text 3"/>
+          <p:cNvSpPr/>
+          <p:nvPr/>
+        </p:nvSpPr>
+        <p:spPr>
+          <a:xfrm>
+            <a:off x="457200" y="1481328"/>
+            <a:ext cx="10972800" cy="502920"/>
+          </a:xfrm>
+          <a:prstGeom prst="rect">
+            <a:avLst/>
+          </a:prstGeom>
+          <a:noFill/>
+          <a:ln/>
+        </p:spPr>
+        <p:txBody>
+          <a:bodyPr wrap="square" rtlCol="0" anchor="t">
+            <a:normAutofit/>
+          </a:bodyPr>
+          <a:lstStyle/>
+          <a:p>
+            <a:pPr indent="0" marL="0">
+              <a:buNone/>
+            </a:pPr>
+            <a:r>
+              <a:rPr lang="en-US" sz="1300" dirty="0">
+                <a:solidFill>
+                  <a:srgbClr val="4A4A4A"/>
+                </a:solidFill>
+                <a:latin typeface="Arial" pitchFamily="34" charset="0"/>
+                <a:ea typeface="Arial" pitchFamily="34" charset="-122"/>
+                <a:cs typeface="Arial" pitchFamily="34" charset="-120"/>
+              </a:rPr>
+              <a:t>Fünfundzwanzig Minuten, fünf Abschnitte. Der meiste Wert liegt in Abschnitt fünf.</a:t>
+            </a:r>
+            <a:endParaRPr lang="en-US" sz="1300" dirty="0"/>
+          </a:p>
+        </p:txBody>
+      </p:sp>
+      <p:sp>
+        <p:nvSpPr>
+          <p:cNvPr id="6" name="Text 4"/>
+          <p:cNvSpPr/>
+          <p:nvPr/>
+        </p:nvSpPr>
+        <p:spPr>
+          <a:xfrm>
+            <a:off x="457200" y="2121408"/>
+            <a:ext cx="10972800" cy="502920"/>
+          </a:xfrm>
+          <a:prstGeom prst="rect">
+            <a:avLst/>
+          </a:prstGeom>
+          <a:noFill/>
+          <a:ln/>
+        </p:spPr>
+        <p:txBody>
+          <a:bodyPr wrap="square" rtlCol="0" anchor="t">
+            <a:normAutofit/>
+          </a:bodyPr>
+          <a:lstStyle/>
+          <a:p>
+            <a:pPr indent="0" marL="0">
+              <a:buNone/>
+            </a:pPr>
+            <a:r>
+              <a:rPr lang="en-US" sz="1600" b="1" dirty="0">
+                <a:solidFill>
+                  <a:srgbClr val="1A1A1A"/>
+                </a:solidFill>
+                <a:latin typeface="Arial" pitchFamily="34" charset="0"/>
+                <a:ea typeface="Arial" pitchFamily="34" charset="-122"/>
+                <a:cs typeface="Arial" pitchFamily="34" charset="-120"/>
+              </a:rPr>
+              <a:t>Warum Logos heute wichtig sind</a:t>
+            </a:r>
+            <a:endParaRPr lang="en-US" sz="1600" dirty="0"/>
+          </a:p>
+        </p:txBody>
+      </p:sp>
+      <p:sp>
+        <p:nvSpPr>
+          <p:cNvPr id="7" name="Text 5"/>
+          <p:cNvSpPr/>
+          <p:nvPr/>
+        </p:nvSpPr>
+        <p:spPr>
+          <a:xfrm>
+            <a:off x="457200" y="2734056"/>
+            <a:ext cx="10972800" cy="502920"/>
+          </a:xfrm>
+          <a:prstGeom prst="rect">
+            <a:avLst/>
+          </a:prstGeom>
+          <a:noFill/>
+          <a:ln/>
+        </p:spPr>
+        <p:txBody>
+          <a:bodyPr wrap="square" rtlCol="0" anchor="t">
+            <a:normAutofit/>
+          </a:bodyPr>
+          <a:lstStyle/>
+          <a:p>
+            <a:pPr indent="0" marL="0">
+              <a:buNone/>
+            </a:pPr>
+            <a:r>
+              <a:rPr lang="en-US" sz="1300" dirty="0">
+                <a:solidFill>
+                  <a:srgbClr val="4A4A4A"/>
+                </a:solidFill>
+                <a:latin typeface="Arial" pitchFamily="34" charset="0"/>
+                <a:ea typeface="Arial" pitchFamily="34" charset="-122"/>
+                <a:cs typeface="Arial" pitchFamily="34" charset="-120"/>
+              </a:rPr>
+              <a:t>Die 2025er Daten zu ersten Eindrücken und Markenvertrauen.</a:t>
+            </a:r>
+            <a:endParaRPr lang="en-US" sz="1300" dirty="0"/>
+          </a:p>
+        </p:txBody>
+      </p:sp>
+      <p:sp>
+        <p:nvSpPr>
+          <p:cNvPr id="8" name="Text 6"/>
+          <p:cNvSpPr/>
+          <p:nvPr/>
+        </p:nvSpPr>
+        <p:spPr>
+          <a:xfrm>
+            <a:off x="457200" y="3374136"/>
+            <a:ext cx="10972800" cy="502920"/>
+          </a:xfrm>
+          <a:prstGeom prst="rect">
+            <a:avLst/>
+          </a:prstGeom>
+          <a:noFill/>
+          <a:ln/>
+        </p:spPr>
+        <p:txBody>
+          <a:bodyPr wrap="square" rtlCol="0" anchor="t">
+            <a:normAutofit/>
+          </a:bodyPr>
+          <a:lstStyle/>
+          <a:p>
+            <a:pPr indent="0" marL="0">
+              <a:buNone/>
+            </a:pPr>
+            <a:r>
+              <a:rPr lang="en-US" sz="1600" b="1" dirty="0">
+                <a:solidFill>
+                  <a:srgbClr val="1A1A1A"/>
+                </a:solidFill>
+                <a:latin typeface="Arial" pitchFamily="34" charset="0"/>
+                <a:ea typeface="Arial" pitchFamily="34" charset="-122"/>
+                <a:cs typeface="Arial" pitchFamily="34" charset="-120"/>
+              </a:rPr>
+              <a:t>Das Produkt</a:t>
+            </a:r>
+            <a:endParaRPr lang="en-US" sz="1600" dirty="0"/>
+          </a:p>
+        </p:txBody>
+      </p:sp>
+      <p:sp>
+        <p:nvSpPr>
+          <p:cNvPr id="9" name="Text 7"/>
+          <p:cNvSpPr/>
+          <p:nvPr/>
+        </p:nvSpPr>
+        <p:spPr>
+          <a:xfrm>
+            <a:off x="457200" y="3986784"/>
+            <a:ext cx="10972800" cy="502920"/>
+          </a:xfrm>
+          <a:prstGeom prst="rect">
+            <a:avLst/>
+          </a:prstGeom>
+          <a:noFill/>
+          <a:ln/>
+        </p:spPr>
+        <p:txBody>
+          <a:bodyPr wrap="square" rtlCol="0" anchor="t">
+            <a:normAutofit/>
+          </a:bodyPr>
+          <a:lstStyle/>
+          <a:p>
+            <a:pPr indent="0" marL="0">
+              <a:buNone/>
+            </a:pPr>
+            <a:r>
+              <a:rPr lang="en-US" sz="1300" dirty="0">
+                <a:solidFill>
+                  <a:srgbClr val="4A4A4A"/>
+                </a:solidFill>
+                <a:latin typeface="Arial" pitchFamily="34" charset="0"/>
+                <a:ea typeface="Arial" pitchFamily="34" charset="-122"/>
+                <a:cs typeface="Arial" pitchFamily="34" charset="-120"/>
+              </a:rPr>
+              <a:t>Was es ist, für wen es ist und was enthalten ist.</a:t>
+            </a:r>
+            <a:endParaRPr lang="en-US" sz="1300" dirty="0"/>
+          </a:p>
+        </p:txBody>
+      </p:sp>
+      <p:sp>
+        <p:nvSpPr>
+          <p:cNvPr id="10" name="Text 8"/>
+          <p:cNvSpPr/>
+          <p:nvPr/>
+        </p:nvSpPr>
+        <p:spPr>
+          <a:xfrm>
+            <a:off x="457200" y="4626864"/>
+            <a:ext cx="10972800" cy="502920"/>
+          </a:xfrm>
+          <a:prstGeom prst="rect">
+            <a:avLst/>
+          </a:prstGeom>
+          <a:noFill/>
+          <a:ln/>
+        </p:spPr>
+        <p:txBody>
+          <a:bodyPr wrap="square" rtlCol="0" anchor="t">
+            <a:normAutofit/>
+          </a:bodyPr>
+          <a:lstStyle/>
+          <a:p>
+            <a:pPr indent="0" marL="0">
+              <a:buNone/>
+            </a:pPr>
+            <a:r>
+              <a:rPr lang="en-US" sz="1600" b="1" dirty="0">
+                <a:solidFill>
+                  <a:srgbClr val="1A1A1A"/>
+                </a:solidFill>
+                <a:latin typeface="Arial" pitchFamily="34" charset="0"/>
+                <a:ea typeface="Arial" pitchFamily="34" charset="-122"/>
+                <a:cs typeface="Arial" pitchFamily="34" charset="-120"/>
+              </a:rPr>
+              <a:t>Der kreative Prozess</a:t>
+            </a:r>
+            <a:endParaRPr lang="en-US" sz="1600" dirty="0"/>
+          </a:p>
+        </p:txBody>
+      </p:sp>
+      <p:sp>
+        <p:nvSpPr>
+          <p:cNvPr id="11" name="Text 9"/>
+          <p:cNvSpPr/>
+          <p:nvPr/>
+        </p:nvSpPr>
+        <p:spPr>
+          <a:xfrm>
+            <a:off x="457200" y="5239512"/>
+            <a:ext cx="10972800" cy="502920"/>
+          </a:xfrm>
+          <a:prstGeom prst="rect">
+            <a:avLst/>
+          </a:prstGeom>
+          <a:noFill/>
+          <a:ln/>
+        </p:spPr>
+        <p:txBody>
+          <a:bodyPr wrap="square" rtlCol="0" anchor="t">
+            <a:normAutofit/>
+          </a:bodyPr>
+          <a:lstStyle/>
+          <a:p>
+            <a:pPr indent="0" marL="0">
+              <a:buNone/>
+            </a:pPr>
+            <a:r>
+              <a:rPr lang="en-US" sz="1300" dirty="0">
+                <a:solidFill>
+                  <a:srgbClr val="4A4A4A"/>
+                </a:solidFill>
+                <a:latin typeface="Arial" pitchFamily="34" charset="0"/>
+                <a:ea typeface="Arial" pitchFamily="34" charset="-122"/>
+                <a:cs typeface="Arial" pitchFamily="34" charset="-120"/>
+              </a:rPr>
+              <a:t>Vom Briefing zu den finalen Dateien in 2–3 Wochen.</a:t>
+            </a:r>
+            <a:endParaRPr lang="en-US" sz="1300" dirty="0"/>
+          </a:p>
+        </p:txBody>
+      </p:sp>
+      <p:sp>
+        <p:nvSpPr>
+          <p:cNvPr id="12" name="Text 10"/>
+          <p:cNvSpPr/>
+          <p:nvPr/>
+        </p:nvSpPr>
+        <p:spPr>
+          <a:xfrm>
+            <a:off x="457200" y="5879592"/>
+            <a:ext cx="10972800" cy="502920"/>
+          </a:xfrm>
+          <a:prstGeom prst="rect">
+            <a:avLst/>
+          </a:prstGeom>
+          <a:noFill/>
+          <a:ln/>
+        </p:spPr>
+        <p:txBody>
+          <a:bodyPr wrap="square" rtlCol="0" anchor="t">
+            <a:normAutofit/>
+          </a:bodyPr>
+          <a:lstStyle/>
+          <a:p>
+            <a:pPr indent="0" marL="0">
+              <a:buNone/>
+            </a:pPr>
+            <a:r>
+              <a:rPr lang="en-US" sz="1600" b="1" dirty="0">
+                <a:solidFill>
+                  <a:srgbClr val="1A1A1A"/>
+                </a:solidFill>
+                <a:latin typeface="Arial" pitchFamily="34" charset="0"/>
+                <a:ea typeface="Arial" pitchFamily="34" charset="-122"/>
+                <a:cs typeface="Arial" pitchFamily="34" charset="-120"/>
+              </a:rPr>
+              <a:t>Pakete und Preise</a:t>
+            </a:r>
+            <a:endParaRPr lang="en-US" sz="1600" dirty="0"/>
+          </a:p>
+        </p:txBody>
+      </p:sp>
     </p:spTree>
   </p:cSld>
   <p:clrMapOvr>
@@ -2822,6 +4099,375 @@
           </a:p>
         </p:txBody>
       </p:sp>
+      <p:sp>
+        <p:nvSpPr>
+          <p:cNvPr id="4" name="Text 2"/>
+          <p:cNvSpPr/>
+          <p:nvPr/>
+        </p:nvSpPr>
+        <p:spPr>
+          <a:xfrm>
+            <a:off x="457200" y="868680"/>
+            <a:ext cx="10972800" cy="502920"/>
+          </a:xfrm>
+          <a:prstGeom prst="rect">
+            <a:avLst/>
+          </a:prstGeom>
+          <a:noFill/>
+          <a:ln/>
+        </p:spPr>
+        <p:txBody>
+          <a:bodyPr wrap="square" rtlCol="0" anchor="t">
+            <a:normAutofit/>
+          </a:bodyPr>
+          <a:lstStyle/>
+          <a:p>
+            <a:pPr indent="0" marL="0">
+              <a:buNone/>
+            </a:pPr>
+            <a:r>
+              <a:rPr lang="en-US" sz="2200" b="1" dirty="0">
+                <a:solidFill>
+                  <a:srgbClr val="1A1A1A"/>
+                </a:solidFill>
+                <a:latin typeface="Arial" pitchFamily="34" charset="0"/>
+                <a:ea typeface="Arial" pitchFamily="34" charset="-122"/>
+                <a:cs typeface="Arial" pitchFamily="34" charset="-120"/>
+              </a:rPr>
+              <a:t>Warum Logos wichtig sind</a:t>
+            </a:r>
+            <a:endParaRPr lang="en-US" sz="2200" dirty="0"/>
+          </a:p>
+        </p:txBody>
+      </p:sp>
+      <p:sp>
+        <p:nvSpPr>
+          <p:cNvPr id="5" name="Text 3"/>
+          <p:cNvSpPr/>
+          <p:nvPr/>
+        </p:nvSpPr>
+        <p:spPr>
+          <a:xfrm>
+            <a:off x="457200" y="1481328"/>
+            <a:ext cx="10972800" cy="668528"/>
+          </a:xfrm>
+          <a:prstGeom prst="rect">
+            <a:avLst/>
+          </a:prstGeom>
+          <a:noFill/>
+          <a:ln/>
+        </p:spPr>
+        <p:txBody>
+          <a:bodyPr wrap="square" rtlCol="0" anchor="t">
+            <a:normAutofit/>
+          </a:bodyPr>
+          <a:lstStyle/>
+          <a:p>
+            <a:pPr indent="0" marL="0">
+              <a:buNone/>
+            </a:pPr>
+            <a:r>
+              <a:rPr lang="en-US" sz="2200" b="1" dirty="0">
+                <a:solidFill>
+                  <a:srgbClr val="1A1A1A"/>
+                </a:solidFill>
+                <a:latin typeface="Arial" pitchFamily="34" charset="0"/>
+                <a:ea typeface="Arial" pitchFamily="34" charset="-122"/>
+                <a:cs typeface="Arial" pitchFamily="34" charset="-120"/>
+              </a:rPr>
+              <a:t>Die Zeit, die Verbraucher brauchen, um einen ersten Eindruck von einem Unternehmen zu gewinnen.</a:t>
+            </a:r>
+            <a:endParaRPr lang="en-US" sz="2200" dirty="0"/>
+          </a:p>
+        </p:txBody>
+      </p:sp>
+      <p:sp>
+        <p:nvSpPr>
+          <p:cNvPr id="6" name="Text 4"/>
+          <p:cNvSpPr/>
+          <p:nvPr/>
+        </p:nvSpPr>
+        <p:spPr>
+          <a:xfrm>
+            <a:off x="457200" y="2259584"/>
+            <a:ext cx="10972800" cy="502920"/>
+          </a:xfrm>
+          <a:prstGeom prst="rect">
+            <a:avLst/>
+          </a:prstGeom>
+          <a:noFill/>
+          <a:ln/>
+        </p:spPr>
+        <p:txBody>
+          <a:bodyPr wrap="square" rtlCol="0" anchor="t">
+            <a:normAutofit/>
+          </a:bodyPr>
+          <a:lstStyle/>
+          <a:p>
+            <a:pPr indent="0" marL="0">
+              <a:buNone/>
+            </a:pPr>
+            <a:r>
+              <a:rPr lang="en-US" sz="1300" dirty="0">
+                <a:solidFill>
+                  <a:srgbClr val="4A4A4A"/>
+                </a:solidFill>
+                <a:latin typeface="Arial" pitchFamily="34" charset="0"/>
+                <a:ea typeface="Arial" pitchFamily="34" charset="-122"/>
+                <a:cs typeface="Arial" pitchFamily="34" charset="-120"/>
+              </a:rPr>
+              <a:t>Ein professionelles Logo ist das stärkste visuelle Signal, das diesen Eindruck prägt — und das Gehirn entscheidet in diesem Moment, ob es einem Unternehmen vertraut.</a:t>
+            </a:r>
+            <a:endParaRPr lang="en-US" sz="1300" dirty="0"/>
+          </a:p>
+        </p:txBody>
+      </p:sp>
+      <p:sp>
+        <p:nvSpPr>
+          <p:cNvPr id="7" name="Text 5"/>
+          <p:cNvSpPr/>
+          <p:nvPr/>
+        </p:nvSpPr>
+        <p:spPr>
+          <a:xfrm>
+            <a:off x="457200" y="2899664"/>
+            <a:ext cx="10972800" cy="502920"/>
+          </a:xfrm>
+          <a:prstGeom prst="rect">
+            <a:avLst/>
+          </a:prstGeom>
+          <a:noFill/>
+          <a:ln/>
+        </p:spPr>
+        <p:txBody>
+          <a:bodyPr wrap="square" rtlCol="0" anchor="t">
+            <a:normAutofit/>
+          </a:bodyPr>
+          <a:lstStyle/>
+          <a:p>
+            <a:pPr indent="0" marL="0">
+              <a:buNone/>
+            </a:pPr>
+            <a:r>
+              <a:rPr lang="en-US" sz="1600" b="1" dirty="0">
+                <a:solidFill>
+                  <a:srgbClr val="1A1A1A"/>
+                </a:solidFill>
+                <a:latin typeface="Arial" pitchFamily="34" charset="0"/>
+                <a:ea typeface="Arial" pitchFamily="34" charset="-122"/>
+                <a:cs typeface="Arial" pitchFamily="34" charset="-120"/>
+              </a:rPr>
+              <a:t>Mehr Wiedererkennung</a:t>
+            </a:r>
+            <a:endParaRPr lang="en-US" sz="1600" dirty="0"/>
+          </a:p>
+        </p:txBody>
+      </p:sp>
+      <p:sp>
+        <p:nvSpPr>
+          <p:cNvPr id="8" name="Text 6"/>
+          <p:cNvSpPr/>
+          <p:nvPr/>
+        </p:nvSpPr>
+        <p:spPr>
+          <a:xfrm>
+            <a:off x="457200" y="3512312"/>
+            <a:ext cx="10972800" cy="502920"/>
+          </a:xfrm>
+          <a:prstGeom prst="rect">
+            <a:avLst/>
+          </a:prstGeom>
+          <a:noFill/>
+          <a:ln/>
+        </p:spPr>
+        <p:txBody>
+          <a:bodyPr wrap="square" rtlCol="0" anchor="t">
+            <a:normAutofit/>
+          </a:bodyPr>
+          <a:lstStyle/>
+          <a:p>
+            <a:pPr indent="0" marL="0">
+              <a:buNone/>
+            </a:pPr>
+            <a:r>
+              <a:rPr lang="en-US" sz="1300" dirty="0">
+                <a:solidFill>
+                  <a:srgbClr val="4A4A4A"/>
+                </a:solidFill>
+                <a:latin typeface="Arial" pitchFamily="34" charset="0"/>
+                <a:ea typeface="Arial" pitchFamily="34" charset="-122"/>
+                <a:cs typeface="Arial" pitchFamily="34" charset="-120"/>
+              </a:rPr>
+              <a:t>Steigerung der Markenwiedererkennung durch ein gut gestaltetes Logo.</a:t>
+            </a:r>
+            <a:endParaRPr lang="en-US" sz="1300" dirty="0"/>
+          </a:p>
+        </p:txBody>
+      </p:sp>
+      <p:sp>
+        <p:nvSpPr>
+          <p:cNvPr id="9" name="Text 7"/>
+          <p:cNvSpPr/>
+          <p:nvPr/>
+        </p:nvSpPr>
+        <p:spPr>
+          <a:xfrm>
+            <a:off x="457200" y="4152392"/>
+            <a:ext cx="10972800" cy="502920"/>
+          </a:xfrm>
+          <a:prstGeom prst="rect">
+            <a:avLst/>
+          </a:prstGeom>
+          <a:noFill/>
+          <a:ln/>
+        </p:spPr>
+        <p:txBody>
+          <a:bodyPr wrap="square" rtlCol="0" anchor="t">
+            <a:normAutofit/>
+          </a:bodyPr>
+          <a:lstStyle/>
+          <a:p>
+            <a:pPr indent="0" marL="0">
+              <a:buNone/>
+            </a:pPr>
+            <a:r>
+              <a:rPr lang="en-US" sz="1600" b="1" dirty="0">
+                <a:solidFill>
+                  <a:srgbClr val="1A1A1A"/>
+                </a:solidFill>
+                <a:latin typeface="Arial" pitchFamily="34" charset="0"/>
+                <a:ea typeface="Arial" pitchFamily="34" charset="-122"/>
+                <a:cs typeface="Arial" pitchFamily="34" charset="-120"/>
+              </a:rPr>
+              <a:t>Mehr Vertrauen</a:t>
+            </a:r>
+            <a:endParaRPr lang="en-US" sz="1600" dirty="0"/>
+          </a:p>
+        </p:txBody>
+      </p:sp>
+      <p:sp>
+        <p:nvSpPr>
+          <p:cNvPr id="10" name="Text 8"/>
+          <p:cNvSpPr/>
+          <p:nvPr/>
+        </p:nvSpPr>
+        <p:spPr>
+          <a:xfrm>
+            <a:off x="457200" y="4765040"/>
+            <a:ext cx="10972800" cy="502920"/>
+          </a:xfrm>
+          <a:prstGeom prst="rect">
+            <a:avLst/>
+          </a:prstGeom>
+          <a:noFill/>
+          <a:ln/>
+        </p:spPr>
+        <p:txBody>
+          <a:bodyPr wrap="square" rtlCol="0" anchor="t">
+            <a:normAutofit/>
+          </a:bodyPr>
+          <a:lstStyle/>
+          <a:p>
+            <a:pPr indent="0" marL="0">
+              <a:buNone/>
+            </a:pPr>
+            <a:r>
+              <a:rPr lang="en-US" sz="1300" dirty="0">
+                <a:solidFill>
+                  <a:srgbClr val="4A4A4A"/>
+                </a:solidFill>
+                <a:latin typeface="Arial" pitchFamily="34" charset="0"/>
+                <a:ea typeface="Arial" pitchFamily="34" charset="-122"/>
+                <a:cs typeface="Arial" pitchFamily="34" charset="-120"/>
+              </a:rPr>
+              <a:t>Vertrauenszuwachs, den Interessenten nach einem hochwertigen Logo empfinden.</a:t>
+            </a:r>
+            <a:endParaRPr lang="en-US" sz="1300" dirty="0"/>
+          </a:p>
+        </p:txBody>
+      </p:sp>
+      <p:sp>
+        <p:nvSpPr>
+          <p:cNvPr id="11" name="Text 9"/>
+          <p:cNvSpPr/>
+          <p:nvPr/>
+        </p:nvSpPr>
+        <p:spPr>
+          <a:xfrm>
+            <a:off x="457200" y="5405120"/>
+            <a:ext cx="10972800" cy="502920"/>
+          </a:xfrm>
+          <a:prstGeom prst="rect">
+            <a:avLst/>
+          </a:prstGeom>
+          <a:noFill/>
+          <a:ln/>
+        </p:spPr>
+        <p:txBody>
+          <a:bodyPr wrap="square" rtlCol="0" anchor="t">
+            <a:normAutofit/>
+          </a:bodyPr>
+          <a:lstStyle/>
+          <a:p>
+            <a:pPr indent="0" marL="0">
+              <a:buNone/>
+            </a:pPr>
+            <a:r>
+              <a:rPr lang="en-US" sz="1600" b="1" dirty="0">
+                <a:solidFill>
+                  <a:srgbClr val="1A1A1A"/>
+                </a:solidFill>
+                <a:latin typeface="Arial" pitchFamily="34" charset="0"/>
+                <a:ea typeface="Arial" pitchFamily="34" charset="-122"/>
+                <a:cs typeface="Arial" pitchFamily="34" charset="-120"/>
+              </a:rPr>
+              <a:t>Gewicht des Eindrucks</a:t>
+            </a:r>
+            <a:endParaRPr lang="en-US" sz="1600" dirty="0"/>
+          </a:p>
+        </p:txBody>
+      </p:sp>
+      <p:sp>
+        <p:nvSpPr>
+          <p:cNvPr id="12" name="Text 10"/>
+          <p:cNvSpPr/>
+          <p:nvPr/>
+        </p:nvSpPr>
+        <p:spPr>
+          <a:xfrm>
+            <a:off x="457200" y="6017768"/>
+            <a:ext cx="10972800" cy="502920"/>
+          </a:xfrm>
+          <a:prstGeom prst="rect">
+            <a:avLst/>
+          </a:prstGeom>
+          <a:noFill/>
+          <a:ln/>
+        </p:spPr>
+        <p:txBody>
+          <a:bodyPr wrap="square" rtlCol="0" anchor="t">
+            <a:normAutofit/>
+          </a:bodyPr>
+          <a:lstStyle/>
+          <a:p>
+            <a:pPr indent="0" marL="0">
+              <a:buNone/>
+            </a:pPr>
+            <a:r>
+              <a:rPr lang="en-US" sz="1300" dirty="0">
+                <a:solidFill>
+                  <a:srgbClr val="4A4A4A"/>
+                </a:solidFill>
+                <a:latin typeface="Arial" pitchFamily="34" charset="0"/>
+                <a:ea typeface="Arial" pitchFamily="34" charset="-122"/>
+                <a:cs typeface="Arial" pitchFamily="34" charset="-120"/>
+              </a:rPr>
+              <a:t>Anteil des ersten Eindrucks, der allein durch die Logo-Farbe bestimmt wird.</a:t>
+            </a:r>
+            <a:endParaRPr lang="en-US" sz="1300" dirty="0"/>
+          </a:p>
+        </p:txBody>
+      </p:sp>
     </p:spTree>
   </p:cSld>
   <p:clrMapOvr>
@@ -2932,6 +4578,375 @@
           </a:p>
         </p:txBody>
       </p:sp>
+      <p:sp>
+        <p:nvSpPr>
+          <p:cNvPr id="4" name="Text 2"/>
+          <p:cNvSpPr/>
+          <p:nvPr/>
+        </p:nvSpPr>
+        <p:spPr>
+          <a:xfrm>
+            <a:off x="457200" y="868680"/>
+            <a:ext cx="10972800" cy="502920"/>
+          </a:xfrm>
+          <a:prstGeom prst="rect">
+            <a:avLst/>
+          </a:prstGeom>
+          <a:noFill/>
+          <a:ln/>
+        </p:spPr>
+        <p:txBody>
+          <a:bodyPr wrap="square" rtlCol="0" anchor="t">
+            <a:normAutofit/>
+          </a:bodyPr>
+          <a:lstStyle/>
+          <a:p>
+            <a:pPr indent="0" marL="0">
+              <a:buNone/>
+            </a:pPr>
+            <a:r>
+              <a:rPr lang="en-US" sz="2200" b="1" dirty="0">
+                <a:solidFill>
+                  <a:srgbClr val="1A1A1A"/>
+                </a:solidFill>
+                <a:latin typeface="Arial" pitchFamily="34" charset="0"/>
+                <a:ea typeface="Arial" pitchFamily="34" charset="-122"/>
+                <a:cs typeface="Arial" pitchFamily="34" charset="-120"/>
+              </a:rPr>
+              <a:t>Was auf dem Spiel steht</a:t>
+            </a:r>
+            <a:endParaRPr lang="en-US" sz="2200" dirty="0"/>
+          </a:p>
+        </p:txBody>
+      </p:sp>
+      <p:sp>
+        <p:nvSpPr>
+          <p:cNvPr id="5" name="Text 3"/>
+          <p:cNvSpPr/>
+          <p:nvPr/>
+        </p:nvSpPr>
+        <p:spPr>
+          <a:xfrm>
+            <a:off x="457200" y="1481328"/>
+            <a:ext cx="10972800" cy="502920"/>
+          </a:xfrm>
+          <a:prstGeom prst="rect">
+            <a:avLst/>
+          </a:prstGeom>
+          <a:noFill/>
+          <a:ln/>
+        </p:spPr>
+        <p:txBody>
+          <a:bodyPr wrap="square" rtlCol="0" anchor="t">
+            <a:normAutofit/>
+          </a:bodyPr>
+          <a:lstStyle/>
+          <a:p>
+            <a:pPr indent="0" marL="0">
+              <a:buNone/>
+            </a:pPr>
+            <a:r>
+              <a:rPr lang="en-US" sz="2200" b="1" dirty="0">
+                <a:solidFill>
+                  <a:srgbClr val="1A1A1A"/>
+                </a:solidFill>
+                <a:latin typeface="Arial" pitchFamily="34" charset="0"/>
+                <a:ea typeface="Arial" pitchFamily="34" charset="-122"/>
+                <a:cs typeface="Arial" pitchFamily="34" charset="-120"/>
+              </a:rPr>
+              <a:t>Die Kosten eines schwachen oder fehlenden Logos.</a:t>
+            </a:r>
+            <a:endParaRPr lang="en-US" sz="2200" dirty="0"/>
+          </a:p>
+        </p:txBody>
+      </p:sp>
+      <p:sp>
+        <p:nvSpPr>
+          <p:cNvPr id="6" name="Text 4"/>
+          <p:cNvSpPr/>
+          <p:nvPr/>
+        </p:nvSpPr>
+        <p:spPr>
+          <a:xfrm>
+            <a:off x="457200" y="2093976"/>
+            <a:ext cx="10972800" cy="502920"/>
+          </a:xfrm>
+          <a:prstGeom prst="rect">
+            <a:avLst/>
+          </a:prstGeom>
+          <a:noFill/>
+          <a:ln/>
+        </p:spPr>
+        <p:txBody>
+          <a:bodyPr wrap="square" rtlCol="0" anchor="t">
+            <a:normAutofit/>
+          </a:bodyPr>
+          <a:lstStyle/>
+          <a:p>
+            <a:pPr indent="0" marL="0">
+              <a:buNone/>
+            </a:pPr>
+            <a:r>
+              <a:rPr lang="en-US" sz="1600" b="1" dirty="0">
+                <a:solidFill>
+                  <a:srgbClr val="1A1A1A"/>
+                </a:solidFill>
+                <a:latin typeface="Arial" pitchFamily="34" charset="0"/>
+                <a:ea typeface="Arial" pitchFamily="34" charset="-122"/>
+                <a:cs typeface="Arial" pitchFamily="34" charset="-120"/>
+              </a:rPr>
+              <a:t>Kosten 01</a:t>
+            </a:r>
+            <a:endParaRPr lang="en-US" sz="1600" dirty="0"/>
+          </a:p>
+        </p:txBody>
+      </p:sp>
+      <p:sp>
+        <p:nvSpPr>
+          <p:cNvPr id="7" name="Text 5"/>
+          <p:cNvSpPr/>
+          <p:nvPr/>
+        </p:nvSpPr>
+        <p:spPr>
+          <a:xfrm>
+            <a:off x="457200" y="2706624"/>
+            <a:ext cx="10972800" cy="502920"/>
+          </a:xfrm>
+          <a:prstGeom prst="rect">
+            <a:avLst/>
+          </a:prstGeom>
+          <a:noFill/>
+          <a:ln/>
+        </p:spPr>
+        <p:txBody>
+          <a:bodyPr wrap="square" rtlCol="0" anchor="t">
+            <a:normAutofit/>
+          </a:bodyPr>
+          <a:lstStyle/>
+          <a:p>
+            <a:pPr indent="0" marL="0">
+              <a:buNone/>
+            </a:pPr>
+            <a:r>
+              <a:rPr lang="en-US" sz="1600" b="1" dirty="0">
+                <a:solidFill>
+                  <a:srgbClr val="1A1A1A"/>
+                </a:solidFill>
+                <a:latin typeface="Arial" pitchFamily="34" charset="0"/>
+                <a:ea typeface="Arial" pitchFamily="34" charset="-122"/>
+                <a:cs typeface="Arial" pitchFamily="34" charset="-120"/>
+              </a:rPr>
+              <a:t>Verlorene Glaubwürdigkeit</a:t>
+            </a:r>
+            <a:endParaRPr lang="en-US" sz="1600" dirty="0"/>
+          </a:p>
+        </p:txBody>
+      </p:sp>
+      <p:sp>
+        <p:nvSpPr>
+          <p:cNvPr id="8" name="Text 6"/>
+          <p:cNvSpPr/>
+          <p:nvPr/>
+        </p:nvSpPr>
+        <p:spPr>
+          <a:xfrm>
+            <a:off x="457200" y="3319272"/>
+            <a:ext cx="10972800" cy="502920"/>
+          </a:xfrm>
+          <a:prstGeom prst="rect">
+            <a:avLst/>
+          </a:prstGeom>
+          <a:noFill/>
+          <a:ln/>
+        </p:spPr>
+        <p:txBody>
+          <a:bodyPr wrap="square" rtlCol="0" anchor="t">
+            <a:normAutofit/>
+          </a:bodyPr>
+          <a:lstStyle/>
+          <a:p>
+            <a:pPr indent="0" marL="0">
+              <a:buNone/>
+            </a:pPr>
+            <a:r>
+              <a:rPr lang="en-US" sz="1300" dirty="0">
+                <a:solidFill>
+                  <a:srgbClr val="4A4A4A"/>
+                </a:solidFill>
+                <a:latin typeface="Arial" pitchFamily="34" charset="0"/>
+                <a:ea typeface="Arial" pitchFamily="34" charset="-122"/>
+                <a:cs typeface="Arial" pitchFamily="34" charset="-120"/>
+              </a:rPr>
+              <a:t>Ein Logo lässt ein Unternehmen etabliert wirken. Ohne eines wählen Interessenten den Wettbewerber, der professioneller aussieht.</a:t>
+            </a:r>
+            <a:endParaRPr lang="en-US" sz="1300" dirty="0"/>
+          </a:p>
+        </p:txBody>
+      </p:sp>
+      <p:sp>
+        <p:nvSpPr>
+          <p:cNvPr id="9" name="Text 7"/>
+          <p:cNvSpPr/>
+          <p:nvPr/>
+        </p:nvSpPr>
+        <p:spPr>
+          <a:xfrm>
+            <a:off x="457200" y="3959352"/>
+            <a:ext cx="10972800" cy="502920"/>
+          </a:xfrm>
+          <a:prstGeom prst="rect">
+            <a:avLst/>
+          </a:prstGeom>
+          <a:noFill/>
+          <a:ln/>
+        </p:spPr>
+        <p:txBody>
+          <a:bodyPr wrap="square" rtlCol="0" anchor="t">
+            <a:normAutofit/>
+          </a:bodyPr>
+          <a:lstStyle/>
+          <a:p>
+            <a:pPr indent="0" marL="0">
+              <a:buNone/>
+            </a:pPr>
+            <a:r>
+              <a:rPr lang="en-US" sz="1600" b="1" dirty="0">
+                <a:solidFill>
+                  <a:srgbClr val="1A1A1A"/>
+                </a:solidFill>
+                <a:latin typeface="Arial" pitchFamily="34" charset="0"/>
+                <a:ea typeface="Arial" pitchFamily="34" charset="-122"/>
+                <a:cs typeface="Arial" pitchFamily="34" charset="-120"/>
+              </a:rPr>
+              <a:t>Kosten 02</a:t>
+            </a:r>
+            <a:endParaRPr lang="en-US" sz="1600" dirty="0"/>
+          </a:p>
+        </p:txBody>
+      </p:sp>
+      <p:sp>
+        <p:nvSpPr>
+          <p:cNvPr id="10" name="Text 8"/>
+          <p:cNvSpPr/>
+          <p:nvPr/>
+        </p:nvSpPr>
+        <p:spPr>
+          <a:xfrm>
+            <a:off x="457200" y="4572000"/>
+            <a:ext cx="10972800" cy="502920"/>
+          </a:xfrm>
+          <a:prstGeom prst="rect">
+            <a:avLst/>
+          </a:prstGeom>
+          <a:noFill/>
+          <a:ln/>
+        </p:spPr>
+        <p:txBody>
+          <a:bodyPr wrap="square" rtlCol="0" anchor="t">
+            <a:normAutofit/>
+          </a:bodyPr>
+          <a:lstStyle/>
+          <a:p>
+            <a:pPr indent="0" marL="0">
+              <a:buNone/>
+            </a:pPr>
+            <a:r>
+              <a:rPr lang="en-US" sz="1600" b="1" dirty="0">
+                <a:solidFill>
+                  <a:srgbClr val="1A1A1A"/>
+                </a:solidFill>
+                <a:latin typeface="Arial" pitchFamily="34" charset="0"/>
+                <a:ea typeface="Arial" pitchFamily="34" charset="-122"/>
+                <a:cs typeface="Arial" pitchFamily="34" charset="-120"/>
+              </a:rPr>
+              <a:t>Verpasste Differenzierung</a:t>
+            </a:r>
+            <a:endParaRPr lang="en-US" sz="1600" dirty="0"/>
+          </a:p>
+        </p:txBody>
+      </p:sp>
+      <p:sp>
+        <p:nvSpPr>
+          <p:cNvPr id="11" name="Text 9"/>
+          <p:cNvSpPr/>
+          <p:nvPr/>
+        </p:nvSpPr>
+        <p:spPr>
+          <a:xfrm>
+            <a:off x="457200" y="5184648"/>
+            <a:ext cx="10972800" cy="502920"/>
+          </a:xfrm>
+          <a:prstGeom prst="rect">
+            <a:avLst/>
+          </a:prstGeom>
+          <a:noFill/>
+          <a:ln/>
+        </p:spPr>
+        <p:txBody>
+          <a:bodyPr wrap="square" rtlCol="0" anchor="t">
+            <a:normAutofit/>
+          </a:bodyPr>
+          <a:lstStyle/>
+          <a:p>
+            <a:pPr indent="0" marL="0">
+              <a:buNone/>
+            </a:pPr>
+            <a:r>
+              <a:rPr lang="en-US" sz="1300" dirty="0">
+                <a:solidFill>
+                  <a:srgbClr val="4A4A4A"/>
+                </a:solidFill>
+                <a:latin typeface="Arial" pitchFamily="34" charset="0"/>
+                <a:ea typeface="Arial" pitchFamily="34" charset="-122"/>
+                <a:cs typeface="Arial" pitchFamily="34" charset="-120"/>
+              </a:rPr>
+              <a:t>Logos sind, wie Kunden ein Unternehmen vom anderen unterscheiden. Eine generische oder fehlende Marke bedeutet, dass Kunden Sie nicht finden.</a:t>
+            </a:r>
+            <a:endParaRPr lang="en-US" sz="1300" dirty="0"/>
+          </a:p>
+        </p:txBody>
+      </p:sp>
+      <p:sp>
+        <p:nvSpPr>
+          <p:cNvPr id="12" name="Text 10"/>
+          <p:cNvSpPr/>
+          <p:nvPr/>
+        </p:nvSpPr>
+        <p:spPr>
+          <a:xfrm>
+            <a:off x="457200" y="5824728"/>
+            <a:ext cx="10972800" cy="502920"/>
+          </a:xfrm>
+          <a:prstGeom prst="rect">
+            <a:avLst/>
+          </a:prstGeom>
+          <a:noFill/>
+          <a:ln/>
+        </p:spPr>
+        <p:txBody>
+          <a:bodyPr wrap="square" rtlCol="0" anchor="t">
+            <a:normAutofit/>
+          </a:bodyPr>
+          <a:lstStyle/>
+          <a:p>
+            <a:pPr indent="0" marL="0">
+              <a:buNone/>
+            </a:pPr>
+            <a:r>
+              <a:rPr lang="en-US" sz="1600" b="1" dirty="0">
+                <a:solidFill>
+                  <a:srgbClr val="1A1A1A"/>
+                </a:solidFill>
+                <a:latin typeface="Arial" pitchFamily="34" charset="0"/>
+                <a:ea typeface="Arial" pitchFamily="34" charset="-122"/>
+                <a:cs typeface="Arial" pitchFamily="34" charset="-120"/>
+              </a:rPr>
+              <a:t>Kosten 03</a:t>
+            </a:r>
+            <a:endParaRPr lang="en-US" sz="1600" dirty="0"/>
+          </a:p>
+        </p:txBody>
+      </p:sp>
     </p:spTree>
   </p:cSld>
   <p:clrMapOvr>
@@ -3042,9 +5057,378 @@
           </a:p>
         </p:txBody>
       </p:sp>
+      <p:sp>
+        <p:nvSpPr>
+          <p:cNvPr id="4" name="Text 2"/>
+          <p:cNvSpPr/>
+          <p:nvPr/>
+        </p:nvSpPr>
+        <p:spPr>
+          <a:xfrm>
+            <a:off x="457200" y="868680"/>
+            <a:ext cx="6949440" cy="502920"/>
+          </a:xfrm>
+          <a:prstGeom prst="rect">
+            <a:avLst/>
+          </a:prstGeom>
+          <a:noFill/>
+          <a:ln/>
+        </p:spPr>
+        <p:txBody>
+          <a:bodyPr wrap="square" rtlCol="0" anchor="t">
+            <a:normAutofit/>
+          </a:bodyPr>
+          <a:lstStyle/>
+          <a:p>
+            <a:pPr indent="0" marL="0">
+              <a:buNone/>
+            </a:pPr>
+            <a:r>
+              <a:rPr lang="en-US" sz="2200" b="1" dirty="0">
+                <a:solidFill>
+                  <a:srgbClr val="1A1A1A"/>
+                </a:solidFill>
+                <a:latin typeface="Arial" pitchFamily="34" charset="0"/>
+                <a:ea typeface="Arial" pitchFamily="34" charset="-122"/>
+                <a:cs typeface="Arial" pitchFamily="34" charset="-120"/>
+              </a:rPr>
+              <a:t>Das Produkt</a:t>
+            </a:r>
+            <a:endParaRPr lang="en-US" sz="2200" dirty="0"/>
+          </a:p>
+        </p:txBody>
+      </p:sp>
+      <p:sp>
+        <p:nvSpPr>
+          <p:cNvPr id="5" name="Text 3"/>
+          <p:cNvSpPr/>
+          <p:nvPr/>
+        </p:nvSpPr>
+        <p:spPr>
+          <a:xfrm>
+            <a:off x="457200" y="1481328"/>
+            <a:ext cx="6949440" cy="502920"/>
+          </a:xfrm>
+          <a:prstGeom prst="rect">
+            <a:avLst/>
+          </a:prstGeom>
+          <a:noFill/>
+          <a:ln/>
+        </p:spPr>
+        <p:txBody>
+          <a:bodyPr wrap="square" rtlCol="0" anchor="t">
+            <a:normAutofit/>
+          </a:bodyPr>
+          <a:lstStyle/>
+          <a:p>
+            <a:pPr indent="0" marL="0">
+              <a:buNone/>
+            </a:pPr>
+            <a:r>
+              <a:rPr lang="en-US" sz="2200" b="1" dirty="0">
+                <a:solidFill>
+                  <a:srgbClr val="1A1A1A"/>
+                </a:solidFill>
+                <a:latin typeface="Arial" pitchFamily="34" charset="0"/>
+                <a:ea typeface="Arial" pitchFamily="34" charset="-122"/>
+                <a:cs typeface="Arial" pitchFamily="34" charset="-120"/>
+              </a:rPr>
+              <a:t>Was es anders macht.</a:t>
+            </a:r>
+            <a:endParaRPr lang="en-US" sz="2200" dirty="0"/>
+          </a:p>
+        </p:txBody>
+      </p:sp>
+      <p:sp>
+        <p:nvSpPr>
+          <p:cNvPr id="6" name="Text 4"/>
+          <p:cNvSpPr/>
+          <p:nvPr/>
+        </p:nvSpPr>
+        <p:spPr>
+          <a:xfrm>
+            <a:off x="457200" y="2093976"/>
+            <a:ext cx="6949440" cy="502920"/>
+          </a:xfrm>
+          <a:prstGeom prst="rect">
+            <a:avLst/>
+          </a:prstGeom>
+          <a:noFill/>
+          <a:ln/>
+        </p:spPr>
+        <p:txBody>
+          <a:bodyPr wrap="square" rtlCol="0" anchor="t">
+            <a:normAutofit/>
+          </a:bodyPr>
+          <a:lstStyle/>
+          <a:p>
+            <a:pPr indent="0" marL="0">
+              <a:buNone/>
+            </a:pPr>
+            <a:r>
+              <a:rPr lang="en-US" sz="1300" dirty="0">
+                <a:solidFill>
+                  <a:srgbClr val="4A4A4A"/>
+                </a:solidFill>
+                <a:latin typeface="Arial" pitchFamily="34" charset="0"/>
+                <a:ea typeface="Arial" pitchFamily="34" charset="-122"/>
+                <a:cs typeface="Arial" pitchFamily="34" charset="-120"/>
+              </a:rPr>
+              <a:t>Vier Produktgrundlagen, die Professionelles Logo-Design von kostenlosen Tools, Freelancern und KI-Generatoren unterscheiden.</a:t>
+            </a:r>
+            <a:endParaRPr lang="en-US" sz="1300" dirty="0"/>
+          </a:p>
+        </p:txBody>
+      </p:sp>
+      <p:sp>
+        <p:nvSpPr>
+          <p:cNvPr id="7" name="Text 5"/>
+          <p:cNvSpPr/>
+          <p:nvPr/>
+        </p:nvSpPr>
+        <p:spPr>
+          <a:xfrm>
+            <a:off x="457200" y="2734056"/>
+            <a:ext cx="6949440" cy="502920"/>
+          </a:xfrm>
+          <a:prstGeom prst="rect">
+            <a:avLst/>
+          </a:prstGeom>
+          <a:noFill/>
+          <a:ln/>
+        </p:spPr>
+        <p:txBody>
+          <a:bodyPr wrap="square" rtlCol="0" anchor="t">
+            <a:normAutofit/>
+          </a:bodyPr>
+          <a:lstStyle/>
+          <a:p>
+            <a:pPr indent="0" marL="0">
+              <a:buNone/>
+            </a:pPr>
+            <a:r>
+              <a:rPr lang="en-US" sz="1600" b="1" dirty="0">
+                <a:solidFill>
+                  <a:srgbClr val="1A1A1A"/>
+                </a:solidFill>
+                <a:latin typeface="Arial" pitchFamily="34" charset="0"/>
+                <a:ea typeface="Arial" pitchFamily="34" charset="-122"/>
+                <a:cs typeface="Arial" pitchFamily="34" charset="-120"/>
+              </a:rPr>
+              <a:t>Menschen, keine Prompts.</a:t>
+            </a:r>
+            <a:endParaRPr lang="en-US" sz="1600" dirty="0"/>
+          </a:p>
+        </p:txBody>
+      </p:sp>
+      <p:sp>
+        <p:nvSpPr>
+          <p:cNvPr id="8" name="Text 6"/>
+          <p:cNvSpPr/>
+          <p:nvPr/>
+        </p:nvSpPr>
+        <p:spPr>
+          <a:xfrm>
+            <a:off x="457200" y="3346704"/>
+            <a:ext cx="6949440" cy="605028"/>
+          </a:xfrm>
+          <a:prstGeom prst="rect">
+            <a:avLst/>
+          </a:prstGeom>
+          <a:noFill/>
+          <a:ln/>
+        </p:spPr>
+        <p:txBody>
+          <a:bodyPr wrap="square" rtlCol="0" anchor="t">
+            <a:normAutofit/>
+          </a:bodyPr>
+          <a:lstStyle/>
+          <a:p>
+            <a:pPr indent="0" marL="0">
+              <a:buNone/>
+            </a:pPr>
+            <a:r>
+              <a:rPr lang="en-US" sz="1300" dirty="0">
+                <a:solidFill>
+                  <a:srgbClr val="4A4A4A"/>
+                </a:solidFill>
+                <a:latin typeface="Arial" pitchFamily="34" charset="0"/>
+                <a:ea typeface="Arial" pitchFamily="34" charset="-122"/>
+                <a:cs typeface="Arial" pitchFamily="34" charset="-120"/>
+              </a:rPr>
+              <a:t>Über zehn Jahre Erfahrung und mehr als 75.000 gelieferte Logos. Bis 2025 sind 20% aller Logos KI-generiert — das macht von Menschen gestaltete Marken differenzierter, nicht weniger.</a:t>
+            </a:r>
+            <a:endParaRPr lang="en-US" sz="1300" dirty="0"/>
+          </a:p>
+        </p:txBody>
+      </p:sp>
+      <p:sp>
+        <p:nvSpPr>
+          <p:cNvPr id="9" name="Text 7"/>
+          <p:cNvSpPr/>
+          <p:nvPr/>
+        </p:nvSpPr>
+        <p:spPr>
+          <a:xfrm>
+            <a:off x="457200" y="4088892"/>
+            <a:ext cx="6949440" cy="502920"/>
+          </a:xfrm>
+          <a:prstGeom prst="rect">
+            <a:avLst/>
+          </a:prstGeom>
+          <a:noFill/>
+          <a:ln/>
+        </p:spPr>
+        <p:txBody>
+          <a:bodyPr wrap="square" rtlCol="0" anchor="t">
+            <a:normAutofit/>
+          </a:bodyPr>
+          <a:lstStyle/>
+          <a:p>
+            <a:pPr indent="0" marL="0">
+              <a:buNone/>
+            </a:pPr>
+            <a:r>
+              <a:rPr lang="en-US" sz="1600" b="1" dirty="0">
+                <a:solidFill>
+                  <a:srgbClr val="1A1A1A"/>
+                </a:solidFill>
+                <a:latin typeface="Arial" pitchFamily="34" charset="0"/>
+                <a:ea typeface="Arial" pitchFamily="34" charset="-122"/>
+                <a:cs typeface="Arial" pitchFamily="34" charset="-120"/>
+              </a:rPr>
+              <a:t>Der Kunde besitzt die Marke vollständig.</a:t>
+            </a:r>
+            <a:endParaRPr lang="en-US" sz="1600" dirty="0"/>
+          </a:p>
+        </p:txBody>
+      </p:sp>
+      <p:sp>
+        <p:nvSpPr>
+          <p:cNvPr id="10" name="Text 8"/>
+          <p:cNvSpPr/>
+          <p:nvPr/>
+        </p:nvSpPr>
+        <p:spPr>
+          <a:xfrm>
+            <a:off x="457200" y="4701540"/>
+            <a:ext cx="6949440" cy="502920"/>
+          </a:xfrm>
+          <a:prstGeom prst="rect">
+            <a:avLst/>
+          </a:prstGeom>
+          <a:noFill/>
+          <a:ln/>
+        </p:spPr>
+        <p:txBody>
+          <a:bodyPr wrap="square" rtlCol="0" anchor="t">
+            <a:normAutofit/>
+          </a:bodyPr>
+          <a:lstStyle/>
+          <a:p>
+            <a:pPr indent="0" marL="0">
+              <a:buNone/>
+            </a:pPr>
+            <a:r>
+              <a:rPr lang="en-US" sz="1300" dirty="0">
+                <a:solidFill>
+                  <a:srgbClr val="4A4A4A"/>
+                </a:solidFill>
+                <a:latin typeface="Arial" pitchFamily="34" charset="0"/>
+                <a:ea typeface="Arial" pitchFamily="34" charset="-122"/>
+                <a:cs typeface="Arial" pitchFamily="34" charset="-120"/>
+              </a:rPr>
+              <a:t>Markenrechtlich schützbar. Lizenzfrei. Eine formelle Rechtsübertragungsurkunde liegt jedem Projekt bei. Kostenlose Tools übertragen selten alle Rechte.</a:t>
+            </a:r>
+            <a:endParaRPr lang="en-US" sz="1300" dirty="0"/>
+          </a:p>
+        </p:txBody>
+      </p:sp>
+      <p:sp>
+        <p:nvSpPr>
+          <p:cNvPr id="11" name="Text 9"/>
+          <p:cNvSpPr/>
+          <p:nvPr/>
+        </p:nvSpPr>
+        <p:spPr>
+          <a:xfrm>
+            <a:off x="457200" y="5341620"/>
+            <a:ext cx="6949440" cy="502920"/>
+          </a:xfrm>
+          <a:prstGeom prst="rect">
+            <a:avLst/>
+          </a:prstGeom>
+          <a:noFill/>
+          <a:ln/>
+        </p:spPr>
+        <p:txBody>
+          <a:bodyPr wrap="square" rtlCol="0" anchor="t">
+            <a:normAutofit/>
+          </a:bodyPr>
+          <a:lstStyle/>
+          <a:p>
+            <a:pPr indent="0" marL="0">
+              <a:buNone/>
+            </a:pPr>
+            <a:r>
+              <a:rPr lang="en-US" sz="1600" b="1" dirty="0">
+                <a:solidFill>
+                  <a:srgbClr val="1A1A1A"/>
+                </a:solidFill>
+                <a:latin typeface="Arial" pitchFamily="34" charset="0"/>
+                <a:ea typeface="Arial" pitchFamily="34" charset="-122"/>
+                <a:cs typeface="Arial" pitchFamily="34" charset="-120"/>
+              </a:rPr>
+              <a:t>Bereit für jede Anwendung.</a:t>
+            </a:r>
+            <a:endParaRPr lang="en-US" sz="1600" dirty="0"/>
+          </a:p>
+        </p:txBody>
+      </p:sp>
+      <p:sp>
+        <p:nvSpPr>
+          <p:cNvPr id="12" name="Text 10"/>
+          <p:cNvSpPr/>
+          <p:nvPr/>
+        </p:nvSpPr>
+        <p:spPr>
+          <a:xfrm>
+            <a:off x="457200" y="5954268"/>
+            <a:ext cx="6949440" cy="502920"/>
+          </a:xfrm>
+          <a:prstGeom prst="rect">
+            <a:avLst/>
+          </a:prstGeom>
+          <a:noFill/>
+          <a:ln/>
+        </p:spPr>
+        <p:txBody>
+          <a:bodyPr wrap="square" rtlCol="0" anchor="t">
+            <a:normAutofit/>
+          </a:bodyPr>
+          <a:lstStyle/>
+          <a:p>
+            <a:pPr indent="0" marL="0">
+              <a:buNone/>
+            </a:pPr>
+            <a:r>
+              <a:rPr lang="en-US" sz="1300" dirty="0">
+                <a:solidFill>
+                  <a:srgbClr val="4A4A4A"/>
+                </a:solidFill>
+                <a:latin typeface="Arial" pitchFamily="34" charset="0"/>
+                <a:ea typeface="Arial" pitchFamily="34" charset="-122"/>
+                <a:cs typeface="Arial" pitchFamily="34" charset="-120"/>
+              </a:rPr>
+              <a:t>AI, EPS, PDF, JPG, PNG, GIF und ICO — sechs Farbversionen und fünf in Schwarz-Weiß. Web, Druck, Merchandise, Social Media, Beschilderung.</a:t>
+            </a:r>
+            <a:endParaRPr lang="en-US" sz="1300" dirty="0"/>
+          </a:p>
+        </p:txBody>
+      </p:sp>
       <p:pic>
         <p:nvPicPr>
-          <p:cNvPr id="4" name="Image 0" descr="preencoded.png">    </p:cNvPr>
+          <p:cNvPr id="13" name="Image 0" descr="preencoded.png">    </p:cNvPr>
           <p:cNvPicPr>
             <a:picLocks noChangeAspect="1"/>
           </p:cNvPicPr>
@@ -3058,8 +5442,8 @@
         </p:blipFill>
         <p:spPr>
           <a:xfrm>
-            <a:off x="7772400" y="1097280"/>
-            <a:ext cx="3657600" cy="2286000"/>
+            <a:off x="7680960" y="1005840"/>
+            <a:ext cx="3840480" cy="2560320"/>
           </a:xfrm>
           <a:prstGeom prst="rect">
             <a:avLst/>
@@ -3176,9 +5560,173 @@
           </a:p>
         </p:txBody>
       </p:sp>
+      <p:sp>
+        <p:nvSpPr>
+          <p:cNvPr id="4" name="Text 2"/>
+          <p:cNvSpPr/>
+          <p:nvPr/>
+        </p:nvSpPr>
+        <p:spPr>
+          <a:xfrm>
+            <a:off x="457200" y="868680"/>
+            <a:ext cx="6949440" cy="502920"/>
+          </a:xfrm>
+          <a:prstGeom prst="rect">
+            <a:avLst/>
+          </a:prstGeom>
+          <a:noFill/>
+          <a:ln/>
+        </p:spPr>
+        <p:txBody>
+          <a:bodyPr wrap="square" rtlCol="0" anchor="t">
+            <a:normAutofit/>
+          </a:bodyPr>
+          <a:lstStyle/>
+          <a:p>
+            <a:pPr indent="0" marL="0">
+              <a:buNone/>
+            </a:pPr>
+            <a:r>
+              <a:rPr lang="en-US" sz="2200" b="1" dirty="0">
+                <a:solidFill>
+                  <a:srgbClr val="1A1A1A"/>
+                </a:solidFill>
+                <a:latin typeface="Arial" pitchFamily="34" charset="0"/>
+                <a:ea typeface="Arial" pitchFamily="34" charset="-122"/>
+                <a:cs typeface="Arial" pitchFamily="34" charset="-120"/>
+              </a:rPr>
+              <a:t>Ausgewählte Arbeiten</a:t>
+            </a:r>
+            <a:endParaRPr lang="en-US" sz="2200" dirty="0"/>
+          </a:p>
+        </p:txBody>
+      </p:sp>
+      <p:sp>
+        <p:nvSpPr>
+          <p:cNvPr id="5" name="Text 3"/>
+          <p:cNvSpPr/>
+          <p:nvPr/>
+        </p:nvSpPr>
+        <p:spPr>
+          <a:xfrm>
+            <a:off x="457200" y="1481328"/>
+            <a:ext cx="6949440" cy="502920"/>
+          </a:xfrm>
+          <a:prstGeom prst="rect">
+            <a:avLst/>
+          </a:prstGeom>
+          <a:noFill/>
+          <a:ln/>
+        </p:spPr>
+        <p:txBody>
+          <a:bodyPr wrap="square" rtlCol="0" anchor="t">
+            <a:normAutofit/>
+          </a:bodyPr>
+          <a:lstStyle/>
+          <a:p>
+            <a:pPr indent="0" marL="0">
+              <a:buNone/>
+            </a:pPr>
+            <a:r>
+              <a:rPr lang="en-US" sz="2200" b="1" dirty="0">
+                <a:solidFill>
+                  <a:srgbClr val="1A1A1A"/>
+                </a:solidFill>
+                <a:latin typeface="Arial" pitchFamily="34" charset="0"/>
+                <a:ea typeface="Arial" pitchFamily="34" charset="-122"/>
+                <a:cs typeface="Arial" pitchFamily="34" charset="-120"/>
+              </a:rPr>
+              <a:t>Einige der Marken, die wir aufgebaut haben.</a:t>
+            </a:r>
+            <a:endParaRPr lang="en-US" sz="2200" dirty="0"/>
+          </a:p>
+        </p:txBody>
+      </p:sp>
+      <p:sp>
+        <p:nvSpPr>
+          <p:cNvPr id="6" name="Text 4"/>
+          <p:cNvSpPr/>
+          <p:nvPr/>
+        </p:nvSpPr>
+        <p:spPr>
+          <a:xfrm>
+            <a:off x="457200" y="2093976"/>
+            <a:ext cx="6949440" cy="502920"/>
+          </a:xfrm>
+          <a:prstGeom prst="rect">
+            <a:avLst/>
+          </a:prstGeom>
+          <a:noFill/>
+          <a:ln/>
+        </p:spPr>
+        <p:txBody>
+          <a:bodyPr wrap="square" rtlCol="0" anchor="t">
+            <a:normAutofit/>
+          </a:bodyPr>
+          <a:lstStyle/>
+          <a:p>
+            <a:pPr indent="0" marL="0">
+              <a:buNone/>
+            </a:pPr>
+            <a:r>
+              <a:rPr lang="en-US" sz="1600" b="1" dirty="0">
+                <a:solidFill>
+                  <a:srgbClr val="1A1A1A"/>
+                </a:solidFill>
+                <a:latin typeface="Arial" pitchFamily="34" charset="0"/>
+                <a:ea typeface="Arial" pitchFamily="34" charset="-122"/>
+                <a:cs typeface="Arial" pitchFamily="34" charset="-120"/>
+              </a:rPr>
+              <a:t>Gelieferte Logos</a:t>
+            </a:r>
+            <a:endParaRPr lang="en-US" sz="1600" dirty="0"/>
+          </a:p>
+        </p:txBody>
+      </p:sp>
+      <p:sp>
+        <p:nvSpPr>
+          <p:cNvPr id="7" name="Text 5"/>
+          <p:cNvSpPr/>
+          <p:nvPr/>
+        </p:nvSpPr>
+        <p:spPr>
+          <a:xfrm>
+            <a:off x="457200" y="2706624"/>
+            <a:ext cx="6949440" cy="502920"/>
+          </a:xfrm>
+          <a:prstGeom prst="rect">
+            <a:avLst/>
+          </a:prstGeom>
+          <a:noFill/>
+          <a:ln/>
+        </p:spPr>
+        <p:txBody>
+          <a:bodyPr wrap="square" rtlCol="0" anchor="t">
+            <a:normAutofit/>
+          </a:bodyPr>
+          <a:lstStyle/>
+          <a:p>
+            <a:pPr indent="0" marL="0">
+              <a:buNone/>
+            </a:pPr>
+            <a:r>
+              <a:rPr lang="en-US" sz="1600" b="1" dirty="0">
+                <a:solidFill>
+                  <a:srgbClr val="1A1A1A"/>
+                </a:solidFill>
+                <a:latin typeface="Arial" pitchFamily="34" charset="0"/>
+                <a:ea typeface="Arial" pitchFamily="34" charset="-122"/>
+                <a:cs typeface="Arial" pitchFamily="34" charset="-120"/>
+              </a:rPr>
+              <a:t>Branchen</a:t>
+            </a:r>
+            <a:endParaRPr lang="en-US" sz="1600" dirty="0"/>
+          </a:p>
+        </p:txBody>
+      </p:sp>
       <p:pic>
         <p:nvPicPr>
-          <p:cNvPr id="4" name="Image 0" descr="preencoded.png">    </p:cNvPr>
+          <p:cNvPr id="8" name="Image 0" descr="preencoded.png">    </p:cNvPr>
           <p:cNvPicPr>
             <a:picLocks noChangeAspect="1"/>
           </p:cNvPicPr>
@@ -3192,8 +5740,200 @@
         </p:blipFill>
         <p:spPr>
           <a:xfrm>
-            <a:off x="7772400" y="1097280"/>
-            <a:ext cx="3657600" cy="2286000"/>
+            <a:off x="7498080" y="914400"/>
+            <a:ext cx="3474720" cy="1463040"/>
+          </a:xfrm>
+          <a:prstGeom prst="rect">
+            <a:avLst/>
+          </a:prstGeom>
+        </p:spPr>
+      </p:pic>
+      <p:pic>
+        <p:nvPicPr>
+          <p:cNvPr id="9" name="Image 1" descr="preencoded.png">    </p:cNvPr>
+          <p:cNvPicPr>
+            <a:picLocks noChangeAspect="1"/>
+          </p:cNvPicPr>
+          <p:nvPr/>
+        </p:nvPicPr>
+        <p:blipFill>
+          <a:blip r:embed="rId2"/>
+          <a:stretch>
+            <a:fillRect/>
+          </a:stretch>
+        </p:blipFill>
+        <p:spPr>
+          <a:xfrm>
+            <a:off x="11109960" y="914400"/>
+            <a:ext cx="3474720" cy="1463040"/>
+          </a:xfrm>
+          <a:prstGeom prst="rect">
+            <a:avLst/>
+          </a:prstGeom>
+        </p:spPr>
+      </p:pic>
+      <p:pic>
+        <p:nvPicPr>
+          <p:cNvPr id="10" name="Image 2" descr="preencoded.png">    </p:cNvPr>
+          <p:cNvPicPr>
+            <a:picLocks noChangeAspect="1"/>
+          </p:cNvPicPr>
+          <p:nvPr/>
+        </p:nvPicPr>
+        <p:blipFill>
+          <a:blip r:embed="rId3"/>
+          <a:stretch>
+            <a:fillRect/>
+          </a:stretch>
+        </p:blipFill>
+        <p:spPr>
+          <a:xfrm>
+            <a:off x="14721840" y="914400"/>
+            <a:ext cx="3474720" cy="1463040"/>
+          </a:xfrm>
+          <a:prstGeom prst="rect">
+            <a:avLst/>
+          </a:prstGeom>
+        </p:spPr>
+      </p:pic>
+      <p:pic>
+        <p:nvPicPr>
+          <p:cNvPr id="11" name="Image 3" descr="preencoded.png">    </p:cNvPr>
+          <p:cNvPicPr>
+            <a:picLocks noChangeAspect="1"/>
+          </p:cNvPicPr>
+          <p:nvPr/>
+        </p:nvPicPr>
+        <p:blipFill>
+          <a:blip r:embed="rId4"/>
+          <a:stretch>
+            <a:fillRect/>
+          </a:stretch>
+        </p:blipFill>
+        <p:spPr>
+          <a:xfrm>
+            <a:off x="7498080" y="2514600"/>
+            <a:ext cx="3474720" cy="1463040"/>
+          </a:xfrm>
+          <a:prstGeom prst="rect">
+            <a:avLst/>
+          </a:prstGeom>
+        </p:spPr>
+      </p:pic>
+      <p:pic>
+        <p:nvPicPr>
+          <p:cNvPr id="12" name="Image 4" descr="preencoded.png">    </p:cNvPr>
+          <p:cNvPicPr>
+            <a:picLocks noChangeAspect="1"/>
+          </p:cNvPicPr>
+          <p:nvPr/>
+        </p:nvPicPr>
+        <p:blipFill>
+          <a:blip r:embed="rId5"/>
+          <a:stretch>
+            <a:fillRect/>
+          </a:stretch>
+        </p:blipFill>
+        <p:spPr>
+          <a:xfrm>
+            <a:off x="11109960" y="2514600"/>
+            <a:ext cx="3474720" cy="1463040"/>
+          </a:xfrm>
+          <a:prstGeom prst="rect">
+            <a:avLst/>
+          </a:prstGeom>
+        </p:spPr>
+      </p:pic>
+      <p:pic>
+        <p:nvPicPr>
+          <p:cNvPr id="13" name="Image 5" descr="preencoded.png">    </p:cNvPr>
+          <p:cNvPicPr>
+            <a:picLocks noChangeAspect="1"/>
+          </p:cNvPicPr>
+          <p:nvPr/>
+        </p:nvPicPr>
+        <p:blipFill>
+          <a:blip r:embed="rId6"/>
+          <a:stretch>
+            <a:fillRect/>
+          </a:stretch>
+        </p:blipFill>
+        <p:spPr>
+          <a:xfrm>
+            <a:off x="14721840" y="2514600"/>
+            <a:ext cx="3474720" cy="1463040"/>
+          </a:xfrm>
+          <a:prstGeom prst="rect">
+            <a:avLst/>
+          </a:prstGeom>
+        </p:spPr>
+      </p:pic>
+      <p:pic>
+        <p:nvPicPr>
+          <p:cNvPr id="14" name="Image 6" descr="preencoded.png">    </p:cNvPr>
+          <p:cNvPicPr>
+            <a:picLocks noChangeAspect="1"/>
+          </p:cNvPicPr>
+          <p:nvPr/>
+        </p:nvPicPr>
+        <p:blipFill>
+          <a:blip r:embed="rId7"/>
+          <a:stretch>
+            <a:fillRect/>
+          </a:stretch>
+        </p:blipFill>
+        <p:spPr>
+          <a:xfrm>
+            <a:off x="7498080" y="4114800"/>
+            <a:ext cx="3474720" cy="1463040"/>
+          </a:xfrm>
+          <a:prstGeom prst="rect">
+            <a:avLst/>
+          </a:prstGeom>
+        </p:spPr>
+      </p:pic>
+      <p:pic>
+        <p:nvPicPr>
+          <p:cNvPr id="15" name="Image 7" descr="preencoded.png">    </p:cNvPr>
+          <p:cNvPicPr>
+            <a:picLocks noChangeAspect="1"/>
+          </p:cNvPicPr>
+          <p:nvPr/>
+        </p:nvPicPr>
+        <p:blipFill>
+          <a:blip r:embed="rId8"/>
+          <a:stretch>
+            <a:fillRect/>
+          </a:stretch>
+        </p:blipFill>
+        <p:spPr>
+          <a:xfrm>
+            <a:off x="11109960" y="4114800"/>
+            <a:ext cx="3474720" cy="1463040"/>
+          </a:xfrm>
+          <a:prstGeom prst="rect">
+            <a:avLst/>
+          </a:prstGeom>
+        </p:spPr>
+      </p:pic>
+      <p:pic>
+        <p:nvPicPr>
+          <p:cNvPr id="16" name="Image 8" descr="preencoded.png">    </p:cNvPr>
+          <p:cNvPicPr>
+            <a:picLocks noChangeAspect="1"/>
+          </p:cNvPicPr>
+          <p:nvPr/>
+        </p:nvPicPr>
+        <p:blipFill>
+          <a:blip r:embed="rId9"/>
+          <a:stretch>
+            <a:fillRect/>
+          </a:stretch>
+        </p:blipFill>
+        <p:spPr>
+          <a:xfrm>
+            <a:off x="14721840" y="4114800"/>
+            <a:ext cx="3474720" cy="1463040"/>
           </a:xfrm>
           <a:prstGeom prst="rect">
             <a:avLst/>
@@ -3310,9 +6050,378 @@
           </a:p>
         </p:txBody>
       </p:sp>
+      <p:sp>
+        <p:nvSpPr>
+          <p:cNvPr id="4" name="Text 2"/>
+          <p:cNvSpPr/>
+          <p:nvPr/>
+        </p:nvSpPr>
+        <p:spPr>
+          <a:xfrm>
+            <a:off x="457200" y="868680"/>
+            <a:ext cx="6949440" cy="502920"/>
+          </a:xfrm>
+          <a:prstGeom prst="rect">
+            <a:avLst/>
+          </a:prstGeom>
+          <a:noFill/>
+          <a:ln/>
+        </p:spPr>
+        <p:txBody>
+          <a:bodyPr wrap="square" rtlCol="0" anchor="t">
+            <a:normAutofit/>
+          </a:bodyPr>
+          <a:lstStyle/>
+          <a:p>
+            <a:pPr indent="0" marL="0">
+              <a:buNone/>
+            </a:pPr>
+            <a:r>
+              <a:rPr lang="en-US" sz="2200" b="1" dirty="0">
+                <a:solidFill>
+                  <a:srgbClr val="1A1A1A"/>
+                </a:solidFill>
+                <a:latin typeface="Arial" pitchFamily="34" charset="0"/>
+                <a:ea typeface="Arial" pitchFamily="34" charset="-122"/>
+                <a:cs typeface="Arial" pitchFamily="34" charset="-120"/>
+              </a:rPr>
+              <a:t>Der kreative Prozess</a:t>
+            </a:r>
+            <a:endParaRPr lang="en-US" sz="2200" dirty="0"/>
+          </a:p>
+        </p:txBody>
+      </p:sp>
+      <p:sp>
+        <p:nvSpPr>
+          <p:cNvPr id="5" name="Text 3"/>
+          <p:cNvSpPr/>
+          <p:nvPr/>
+        </p:nvSpPr>
+        <p:spPr>
+          <a:xfrm>
+            <a:off x="457200" y="1481328"/>
+            <a:ext cx="6949440" cy="502920"/>
+          </a:xfrm>
+          <a:prstGeom prst="rect">
+            <a:avLst/>
+          </a:prstGeom>
+          <a:noFill/>
+          <a:ln/>
+        </p:spPr>
+        <p:txBody>
+          <a:bodyPr wrap="square" rtlCol="0" anchor="t">
+            <a:normAutofit/>
+          </a:bodyPr>
+          <a:lstStyle/>
+          <a:p>
+            <a:pPr indent="0" marL="0">
+              <a:buNone/>
+            </a:pPr>
+            <a:r>
+              <a:rPr lang="en-US" sz="2200" b="1" dirty="0">
+                <a:solidFill>
+                  <a:srgbClr val="1A1A1A"/>
+                </a:solidFill>
+                <a:latin typeface="Arial" pitchFamily="34" charset="0"/>
+                <a:ea typeface="Arial" pitchFamily="34" charset="-122"/>
+                <a:cs typeface="Arial" pitchFamily="34" charset="-120"/>
+              </a:rPr>
+              <a:t>Vom Briefing zu den finalen Dateien.</a:t>
+            </a:r>
+            <a:endParaRPr lang="en-US" sz="2200" dirty="0"/>
+          </a:p>
+        </p:txBody>
+      </p:sp>
+      <p:sp>
+        <p:nvSpPr>
+          <p:cNvPr id="6" name="Text 4"/>
+          <p:cNvSpPr/>
+          <p:nvPr/>
+        </p:nvSpPr>
+        <p:spPr>
+          <a:xfrm>
+            <a:off x="457200" y="2093976"/>
+            <a:ext cx="6949440" cy="502920"/>
+          </a:xfrm>
+          <a:prstGeom prst="rect">
+            <a:avLst/>
+          </a:prstGeom>
+          <a:noFill/>
+          <a:ln/>
+        </p:spPr>
+        <p:txBody>
+          <a:bodyPr wrap="square" rtlCol="0" anchor="t">
+            <a:normAutofit/>
+          </a:bodyPr>
+          <a:lstStyle/>
+          <a:p>
+            <a:pPr indent="0" marL="0">
+              <a:buNone/>
+            </a:pPr>
+            <a:r>
+              <a:rPr lang="en-US" sz="1600" b="1" dirty="0">
+                <a:solidFill>
+                  <a:srgbClr val="1A1A1A"/>
+                </a:solidFill>
+                <a:latin typeface="Arial" pitchFamily="34" charset="0"/>
+                <a:ea typeface="Arial" pitchFamily="34" charset="-122"/>
+                <a:cs typeface="Arial" pitchFamily="34" charset="-120"/>
+              </a:rPr>
+              <a:t>Kauf &amp; Willkommen</a:t>
+            </a:r>
+            <a:endParaRPr lang="en-US" sz="1600" dirty="0"/>
+          </a:p>
+        </p:txBody>
+      </p:sp>
+      <p:sp>
+        <p:nvSpPr>
+          <p:cNvPr id="7" name="Text 5"/>
+          <p:cNvSpPr/>
+          <p:nvPr/>
+        </p:nvSpPr>
+        <p:spPr>
+          <a:xfrm>
+            <a:off x="457200" y="2706624"/>
+            <a:ext cx="6949440" cy="502920"/>
+          </a:xfrm>
+          <a:prstGeom prst="rect">
+            <a:avLst/>
+          </a:prstGeom>
+          <a:noFill/>
+          <a:ln/>
+        </p:spPr>
+        <p:txBody>
+          <a:bodyPr wrap="square" rtlCol="0" anchor="t">
+            <a:normAutofit/>
+          </a:bodyPr>
+          <a:lstStyle/>
+          <a:p>
+            <a:pPr indent="0" marL="0">
+              <a:buNone/>
+            </a:pPr>
+            <a:r>
+              <a:rPr lang="en-US" sz="1300" dirty="0">
+                <a:solidFill>
+                  <a:srgbClr val="4A4A4A"/>
+                </a:solidFill>
+                <a:latin typeface="Arial" pitchFamily="34" charset="0"/>
+                <a:ea typeface="Arial" pitchFamily="34" charset="-122"/>
+                <a:cs typeface="Arial" pitchFamily="34" charset="-120"/>
+              </a:rPr>
+              <a:t>Der Kunde kauft ein Paket und erhält eine Willkommens-E-Mail zur Auftragsbestätigung.</a:t>
+            </a:r>
+            <a:endParaRPr lang="en-US" sz="1300" dirty="0"/>
+          </a:p>
+        </p:txBody>
+      </p:sp>
+      <p:sp>
+        <p:nvSpPr>
+          <p:cNvPr id="8" name="Text 6"/>
+          <p:cNvSpPr/>
+          <p:nvPr/>
+        </p:nvSpPr>
+        <p:spPr>
+          <a:xfrm>
+            <a:off x="457200" y="3346704"/>
+            <a:ext cx="6949440" cy="502920"/>
+          </a:xfrm>
+          <a:prstGeom prst="rect">
+            <a:avLst/>
+          </a:prstGeom>
+          <a:noFill/>
+          <a:ln/>
+        </p:spPr>
+        <p:txBody>
+          <a:bodyPr wrap="square" rtlCol="0" anchor="t">
+            <a:normAutofit/>
+          </a:bodyPr>
+          <a:lstStyle/>
+          <a:p>
+            <a:pPr indent="0" marL="0">
+              <a:buNone/>
+            </a:pPr>
+            <a:r>
+              <a:rPr lang="en-US" sz="1600" b="1" dirty="0">
+                <a:solidFill>
+                  <a:srgbClr val="1A1A1A"/>
+                </a:solidFill>
+                <a:latin typeface="Arial" pitchFamily="34" charset="0"/>
+                <a:ea typeface="Arial" pitchFamily="34" charset="-122"/>
+                <a:cs typeface="Arial" pitchFamily="34" charset="-120"/>
+              </a:rPr>
+              <a:t>Koordinator kontaktiert</a:t>
+            </a:r>
+            <a:endParaRPr lang="en-US" sz="1600" dirty="0"/>
+          </a:p>
+        </p:txBody>
+      </p:sp>
+      <p:sp>
+        <p:nvSpPr>
+          <p:cNvPr id="9" name="Text 7"/>
+          <p:cNvSpPr/>
+          <p:nvPr/>
+        </p:nvSpPr>
+        <p:spPr>
+          <a:xfrm>
+            <a:off x="457200" y="3959352"/>
+            <a:ext cx="6949440" cy="502920"/>
+          </a:xfrm>
+          <a:prstGeom prst="rect">
+            <a:avLst/>
+          </a:prstGeom>
+          <a:noFill/>
+          <a:ln/>
+        </p:spPr>
+        <p:txBody>
+          <a:bodyPr wrap="square" rtlCol="0" anchor="t">
+            <a:normAutofit/>
+          </a:bodyPr>
+          <a:lstStyle/>
+          <a:p>
+            <a:pPr indent="0" marL="0">
+              <a:buNone/>
+            </a:pPr>
+            <a:r>
+              <a:rPr lang="en-US" sz="1300" dirty="0">
+                <a:solidFill>
+                  <a:srgbClr val="4A4A4A"/>
+                </a:solidFill>
+                <a:latin typeface="Arial" pitchFamily="34" charset="0"/>
+                <a:ea typeface="Arial" pitchFamily="34" charset="-122"/>
+                <a:cs typeface="Arial" pitchFamily="34" charset="-120"/>
+              </a:rPr>
+              <a:t>Ein dedizierter Logo-Design-Koordinator sammelt das kreative Briefing — Ziele, Stil, Farben, Referenzen.</a:t>
+            </a:r>
+            <a:endParaRPr lang="en-US" sz="1300" dirty="0"/>
+          </a:p>
+        </p:txBody>
+      </p:sp>
+      <p:sp>
+        <p:nvSpPr>
+          <p:cNvPr id="10" name="Text 8"/>
+          <p:cNvSpPr/>
+          <p:nvPr/>
+        </p:nvSpPr>
+        <p:spPr>
+          <a:xfrm>
+            <a:off x="457200" y="4599432"/>
+            <a:ext cx="6949440" cy="502920"/>
+          </a:xfrm>
+          <a:prstGeom prst="rect">
+            <a:avLst/>
+          </a:prstGeom>
+          <a:noFill/>
+          <a:ln/>
+        </p:spPr>
+        <p:txBody>
+          <a:bodyPr wrap="square" rtlCol="0" anchor="t">
+            <a:normAutofit/>
+          </a:bodyPr>
+          <a:lstStyle/>
+          <a:p>
+            <a:pPr indent="0" marL="0">
+              <a:buNone/>
+            </a:pPr>
+            <a:r>
+              <a:rPr lang="en-US" sz="1600" b="1" dirty="0">
+                <a:solidFill>
+                  <a:srgbClr val="1A1A1A"/>
+                </a:solidFill>
+                <a:latin typeface="Arial" pitchFamily="34" charset="0"/>
+                <a:ea typeface="Arial" pitchFamily="34" charset="-122"/>
+                <a:cs typeface="Arial" pitchFamily="34" charset="-120"/>
+              </a:rPr>
+              <a:t>Erste Konzepte</a:t>
+            </a:r>
+            <a:endParaRPr lang="en-US" sz="1600" dirty="0"/>
+          </a:p>
+        </p:txBody>
+      </p:sp>
+      <p:sp>
+        <p:nvSpPr>
+          <p:cNvPr id="11" name="Text 9"/>
+          <p:cNvSpPr/>
+          <p:nvPr/>
+        </p:nvSpPr>
+        <p:spPr>
+          <a:xfrm>
+            <a:off x="457200" y="5212080"/>
+            <a:ext cx="6949440" cy="502920"/>
+          </a:xfrm>
+          <a:prstGeom prst="rect">
+            <a:avLst/>
+          </a:prstGeom>
+          <a:noFill/>
+          <a:ln/>
+        </p:spPr>
+        <p:txBody>
+          <a:bodyPr wrap="square" rtlCol="0" anchor="t">
+            <a:normAutofit/>
+          </a:bodyPr>
+          <a:lstStyle/>
+          <a:p>
+            <a:pPr indent="0" marL="0">
+              <a:buNone/>
+            </a:pPr>
+            <a:r>
+              <a:rPr lang="en-US" sz="1300" dirty="0">
+                <a:solidFill>
+                  <a:srgbClr val="4A4A4A"/>
+                </a:solidFill>
+                <a:latin typeface="Arial" pitchFamily="34" charset="0"/>
+                <a:ea typeface="Arial" pitchFamily="34" charset="-122"/>
+                <a:cs typeface="Arial" pitchFamily="34" charset="-120"/>
+              </a:rPr>
+              <a:t>Hausinterne Designer liefern bis zu zehn individuelle Konzepte auf Basis des Briefings.</a:t>
+            </a:r>
+            <a:endParaRPr lang="en-US" sz="1300" dirty="0"/>
+          </a:p>
+        </p:txBody>
+      </p:sp>
+      <p:sp>
+        <p:nvSpPr>
+          <p:cNvPr id="12" name="Text 10"/>
+          <p:cNvSpPr/>
+          <p:nvPr/>
+        </p:nvSpPr>
+        <p:spPr>
+          <a:xfrm>
+            <a:off x="457200" y="5852160"/>
+            <a:ext cx="6949440" cy="502920"/>
+          </a:xfrm>
+          <a:prstGeom prst="rect">
+            <a:avLst/>
+          </a:prstGeom>
+          <a:noFill/>
+          <a:ln/>
+        </p:spPr>
+        <p:txBody>
+          <a:bodyPr wrap="square" rtlCol="0" anchor="t">
+            <a:normAutofit/>
+          </a:bodyPr>
+          <a:lstStyle/>
+          <a:p>
+            <a:pPr indent="0" marL="0">
+              <a:buNone/>
+            </a:pPr>
+            <a:r>
+              <a:rPr lang="en-US" sz="1600" b="1" dirty="0">
+                <a:solidFill>
+                  <a:srgbClr val="1A1A1A"/>
+                </a:solidFill>
+                <a:latin typeface="Arial" pitchFamily="34" charset="0"/>
+                <a:ea typeface="Arial" pitchFamily="34" charset="-122"/>
+                <a:cs typeface="Arial" pitchFamily="34" charset="-120"/>
+              </a:rPr>
+              <a:t>Revisionen</a:t>
+            </a:r>
+            <a:endParaRPr lang="en-US" sz="1600" dirty="0"/>
+          </a:p>
+        </p:txBody>
+      </p:sp>
       <p:pic>
         <p:nvPicPr>
-          <p:cNvPr id="4" name="Image 0" descr="preencoded.png">    </p:cNvPr>
+          <p:cNvPr id="13" name="Image 0" descr="preencoded.png">    </p:cNvPr>
           <p:cNvPicPr>
             <a:picLocks noChangeAspect="1"/>
           </p:cNvPicPr>
@@ -3326,8 +6435,8 @@
         </p:blipFill>
         <p:spPr>
           <a:xfrm>
-            <a:off x="7772400" y="1097280"/>
-            <a:ext cx="3657600" cy="2286000"/>
+            <a:off x="7680960" y="1005840"/>
+            <a:ext cx="3840480" cy="2560320"/>
           </a:xfrm>
           <a:prstGeom prst="rect">
             <a:avLst/>
@@ -3444,6 +6553,357 @@
           </a:p>
         </p:txBody>
       </p:sp>
+      <p:sp>
+        <p:nvSpPr>
+          <p:cNvPr id="4" name="Text 2"/>
+          <p:cNvSpPr/>
+          <p:nvPr/>
+        </p:nvSpPr>
+        <p:spPr>
+          <a:xfrm>
+            <a:off x="457200" y="868680"/>
+            <a:ext cx="10972800" cy="502920"/>
+          </a:xfrm>
+          <a:prstGeom prst="rect">
+            <a:avLst/>
+          </a:prstGeom>
+          <a:noFill/>
+          <a:ln/>
+        </p:spPr>
+        <p:txBody>
+          <a:bodyPr wrap="square" rtlCol="0" anchor="t">
+            <a:normAutofit/>
+          </a:bodyPr>
+          <a:lstStyle/>
+          <a:p>
+            <a:pPr indent="0" marL="0">
+              <a:buNone/>
+            </a:pPr>
+            <a:r>
+              <a:rPr lang="en-US" sz="2200" b="1" dirty="0">
+                <a:solidFill>
+                  <a:srgbClr val="1A1A1A"/>
+                </a:solidFill>
+                <a:latin typeface="Arial" pitchFamily="34" charset="0"/>
+                <a:ea typeface="Arial" pitchFamily="34" charset="-122"/>
+                <a:cs typeface="Arial" pitchFamily="34" charset="-120"/>
+              </a:rPr>
+              <a:t>Pakete &amp; Preise</a:t>
+            </a:r>
+            <a:endParaRPr lang="en-US" sz="2200" dirty="0"/>
+          </a:p>
+        </p:txBody>
+      </p:sp>
+      <p:sp>
+        <p:nvSpPr>
+          <p:cNvPr id="5" name="Text 3"/>
+          <p:cNvSpPr/>
+          <p:nvPr/>
+        </p:nvSpPr>
+        <p:spPr>
+          <a:xfrm>
+            <a:off x="457200" y="1481328"/>
+            <a:ext cx="10972800" cy="502920"/>
+          </a:xfrm>
+          <a:prstGeom prst="rect">
+            <a:avLst/>
+          </a:prstGeom>
+          <a:noFill/>
+          <a:ln/>
+        </p:spPr>
+        <p:txBody>
+          <a:bodyPr wrap="square" rtlCol="0" anchor="t">
+            <a:normAutofit/>
+          </a:bodyPr>
+          <a:lstStyle/>
+          <a:p>
+            <a:pPr indent="0" marL="0">
+              <a:buNone/>
+            </a:pPr>
+            <a:r>
+              <a:rPr lang="en-US" sz="2200" b="1" dirty="0">
+                <a:solidFill>
+                  <a:srgbClr val="1A1A1A"/>
+                </a:solidFill>
+                <a:latin typeface="Arial" pitchFamily="34" charset="0"/>
+                <a:ea typeface="Arial" pitchFamily="34" charset="-122"/>
+                <a:cs typeface="Arial" pitchFamily="34" charset="-120"/>
+              </a:rPr>
+              <a:t>Drei Stufen für jedes Budget.</a:t>
+            </a:r>
+            <a:endParaRPr lang="en-US" sz="2200" dirty="0"/>
+          </a:p>
+        </p:txBody>
+      </p:sp>
+      <p:sp>
+        <p:nvSpPr>
+          <p:cNvPr id="6" name="Text 4"/>
+          <p:cNvSpPr/>
+          <p:nvPr/>
+        </p:nvSpPr>
+        <p:spPr>
+          <a:xfrm>
+            <a:off x="457200" y="2093976"/>
+            <a:ext cx="10972800" cy="502920"/>
+          </a:xfrm>
+          <a:prstGeom prst="rect">
+            <a:avLst/>
+          </a:prstGeom>
+          <a:noFill/>
+          <a:ln/>
+        </p:spPr>
+        <p:txBody>
+          <a:bodyPr wrap="square" rtlCol="0" anchor="t">
+            <a:normAutofit/>
+          </a:bodyPr>
+          <a:lstStyle/>
+          <a:p>
+            <a:pPr indent="0" marL="0">
+              <a:buNone/>
+            </a:pPr>
+            <a:r>
+              <a:rPr lang="en-US" sz="1300" dirty="0">
+                <a:solidFill>
+                  <a:srgbClr val="4A4A4A"/>
+                </a:solidFill>
+                <a:latin typeface="Arial" pitchFamily="34" charset="0"/>
+                <a:ea typeface="Arial" pitchFamily="34" charset="-122"/>
+                <a:cs typeface="Arial" pitchFamily="34" charset="-120"/>
+              </a:rPr>
+              <a:t>Alle Pakete enthalten den Logo-Design-Koordinator, drei Revisionsrunden, das 11-Format-Dateipaket und volle Eigentumsrechte am finalen Design.</a:t>
+            </a:r>
+            <a:endParaRPr lang="en-US" sz="1300" dirty="0"/>
+          </a:p>
+        </p:txBody>
+      </p:sp>
+      <p:sp>
+        <p:nvSpPr>
+          <p:cNvPr id="7" name="Text 5"/>
+          <p:cNvSpPr/>
+          <p:nvPr/>
+        </p:nvSpPr>
+        <p:spPr>
+          <a:xfrm>
+            <a:off x="594360" y="2734056"/>
+            <a:ext cx="10789920" cy="1783080"/>
+          </a:xfrm>
+          <a:prstGeom prst="rect">
+            <a:avLst/>
+          </a:prstGeom>
+          <a:noFill/>
+          <a:ln/>
+        </p:spPr>
+        <p:txBody>
+          <a:bodyPr wrap="square" rtlCol="0" anchor="t">
+            <a:normAutofit/>
+          </a:bodyPr>
+          <a:lstStyle/>
+          <a:p>
+            <a:pPr marL="342900" indent="-342900">
+              <a:buSzPct val="100000"/>
+              <a:buChar char="•"/>
+            </a:pPr>
+            <a:r>
+              <a:rPr lang="en-US" sz="1200" dirty="0">
+                <a:solidFill>
+                  <a:srgbClr val="4A4A4A"/>
+                </a:solidFill>
+                <a:latin typeface="Arial" pitchFamily="34" charset="0"/>
+                <a:ea typeface="Arial" pitchFamily="34" charset="-122"/>
+                <a:cs typeface="Arial" pitchFamily="34" charset="-120"/>
+              </a:rPr>
+              <a:t>Logo-Design-Koordinator</a:t>
+            </a:r>
+            <a:endParaRPr lang="en-US" sz="1200" dirty="0"/>
+          </a:p>
+          <a:p>
+            <a:pPr marL="342900" indent="-342900">
+              <a:buSzPct val="100000"/>
+              <a:buChar char="•"/>
+            </a:pPr>
+            <a:r>
+              <a:rPr lang="en-US" sz="1200" dirty="0">
+                <a:solidFill>
+                  <a:srgbClr val="4A4A4A"/>
+                </a:solidFill>
+                <a:latin typeface="Arial" pitchFamily="34" charset="0"/>
+                <a:ea typeface="Arial" pitchFamily="34" charset="-122"/>
+                <a:cs typeface="Arial" pitchFamily="34" charset="-120"/>
+              </a:rPr>
+              <a:t>4 individuelle Designkonzepte</a:t>
+            </a:r>
+            <a:endParaRPr lang="en-US" sz="1200" dirty="0"/>
+          </a:p>
+          <a:p>
+            <a:pPr marL="342900" indent="-342900">
+              <a:buSzPct val="100000"/>
+              <a:buChar char="•"/>
+            </a:pPr>
+            <a:r>
+              <a:rPr lang="en-US" sz="1200" dirty="0">
+                <a:solidFill>
+                  <a:srgbClr val="4A4A4A"/>
+                </a:solidFill>
+                <a:latin typeface="Arial" pitchFamily="34" charset="0"/>
+                <a:ea typeface="Arial" pitchFamily="34" charset="-122"/>
+                <a:cs typeface="Arial" pitchFamily="34" charset="-120"/>
+              </a:rPr>
+              <a:t>3 Revisionsrunden</a:t>
+            </a:r>
+            <a:endParaRPr lang="en-US" sz="1200" dirty="0"/>
+          </a:p>
+          <a:p>
+            <a:pPr marL="342900" indent="-342900">
+              <a:buSzPct val="100000"/>
+              <a:buChar char="•"/>
+            </a:pPr>
+            <a:r>
+              <a:rPr lang="en-US" sz="1200" dirty="0">
+                <a:solidFill>
+                  <a:srgbClr val="4A4A4A"/>
+                </a:solidFill>
+                <a:latin typeface="Arial" pitchFamily="34" charset="0"/>
+                <a:ea typeface="Arial" pitchFamily="34" charset="-122"/>
+                <a:cs typeface="Arial" pitchFamily="34" charset="-120"/>
+              </a:rPr>
+              <a:t>11 finale Dateiformate</a:t>
+            </a:r>
+            <a:endParaRPr lang="en-US" sz="1200" dirty="0"/>
+          </a:p>
+          <a:p>
+            <a:pPr marL="342900" indent="-342900">
+              <a:buSzPct val="100000"/>
+              <a:buChar char="•"/>
+            </a:pPr>
+            <a:r>
+              <a:rPr lang="en-US" sz="1200" dirty="0">
+                <a:solidFill>
+                  <a:srgbClr val="4A4A4A"/>
+                </a:solidFill>
+                <a:latin typeface="Arial" pitchFamily="34" charset="0"/>
+                <a:ea typeface="Arial" pitchFamily="34" charset="-122"/>
+                <a:cs typeface="Arial" pitchFamily="34" charset="-120"/>
+              </a:rPr>
+              <a:t>Volle Eigentumsrechte am Design</a:t>
+            </a:r>
+            <a:endParaRPr lang="en-US" sz="1200" dirty="0"/>
+          </a:p>
+        </p:txBody>
+      </p:sp>
+      <p:sp>
+        <p:nvSpPr>
+          <p:cNvPr id="8" name="Text 6"/>
+          <p:cNvSpPr/>
+          <p:nvPr/>
+        </p:nvSpPr>
+        <p:spPr>
+          <a:xfrm>
+            <a:off x="594360" y="4654296"/>
+            <a:ext cx="10789920" cy="1783080"/>
+          </a:xfrm>
+          <a:prstGeom prst="rect">
+            <a:avLst/>
+          </a:prstGeom>
+          <a:noFill/>
+          <a:ln/>
+        </p:spPr>
+        <p:txBody>
+          <a:bodyPr wrap="square" rtlCol="0" anchor="t">
+            <a:normAutofit/>
+          </a:bodyPr>
+          <a:lstStyle/>
+          <a:p>
+            <a:pPr marL="342900" indent="-342900">
+              <a:buSzPct val="100000"/>
+              <a:buChar char="•"/>
+            </a:pPr>
+            <a:r>
+              <a:rPr lang="en-US" sz="1200" dirty="0">
+                <a:solidFill>
+                  <a:srgbClr val="4A4A4A"/>
+                </a:solidFill>
+                <a:latin typeface="Arial" pitchFamily="34" charset="0"/>
+                <a:ea typeface="Arial" pitchFamily="34" charset="-122"/>
+                <a:cs typeface="Arial" pitchFamily="34" charset="-120"/>
+              </a:rPr>
+              <a:t>Alles aus Bronze</a:t>
+            </a:r>
+            <a:endParaRPr lang="en-US" sz="1200" dirty="0"/>
+          </a:p>
+          <a:p>
+            <a:pPr marL="342900" indent="-342900">
+              <a:buSzPct val="100000"/>
+              <a:buChar char="•"/>
+            </a:pPr>
+            <a:r>
+              <a:rPr lang="en-US" sz="1200" dirty="0">
+                <a:solidFill>
+                  <a:srgbClr val="4A4A4A"/>
+                </a:solidFill>
+                <a:latin typeface="Arial" pitchFamily="34" charset="0"/>
+                <a:ea typeface="Arial" pitchFamily="34" charset="-122"/>
+                <a:cs typeface="Arial" pitchFamily="34" charset="-120"/>
+              </a:rPr>
+              <a:t>6 individuelle Designkonzepte</a:t>
+            </a:r>
+            <a:endParaRPr lang="en-US" sz="1200" dirty="0"/>
+          </a:p>
+          <a:p>
+            <a:pPr marL="342900" indent="-342900">
+              <a:buSzPct val="100000"/>
+              <a:buChar char="•"/>
+            </a:pPr>
+            <a:r>
+              <a:rPr lang="en-US" sz="1200" dirty="0">
+                <a:solidFill>
+                  <a:srgbClr val="4A4A4A"/>
+                </a:solidFill>
+                <a:latin typeface="Arial" pitchFamily="34" charset="0"/>
+                <a:ea typeface="Arial" pitchFamily="34" charset="-122"/>
+                <a:cs typeface="Arial" pitchFamily="34" charset="-120"/>
+              </a:rPr>
+              <a:t>Visitenkartendesign</a:t>
+            </a:r>
+            <a:endParaRPr lang="en-US" sz="1200" dirty="0"/>
+          </a:p>
+          <a:p>
+            <a:pPr marL="342900" indent="-342900">
+              <a:buSzPct val="100000"/>
+              <a:buChar char="•"/>
+            </a:pPr>
+            <a:r>
+              <a:rPr lang="en-US" sz="1200" dirty="0">
+                <a:solidFill>
+                  <a:srgbClr val="4A4A4A"/>
+                </a:solidFill>
+                <a:latin typeface="Arial" pitchFamily="34" charset="0"/>
+                <a:ea typeface="Arial" pitchFamily="34" charset="-122"/>
+                <a:cs typeface="Arial" pitchFamily="34" charset="-120"/>
+              </a:rPr>
+              <a:t>Briefbogen &amp; Umschlag</a:t>
+            </a:r>
+            <a:endParaRPr lang="en-US" sz="1200" dirty="0"/>
+          </a:p>
+          <a:p>
+            <a:pPr marL="342900" indent="-342900">
+              <a:buSzPct val="100000"/>
+              <a:buChar char="•"/>
+            </a:pPr>
+            <a:r>
+              <a:rPr lang="en-US" sz="1200" dirty="0">
+                <a:solidFill>
+                  <a:srgbClr val="4A4A4A"/>
+                </a:solidFill>
+                <a:latin typeface="Arial" pitchFamily="34" charset="0"/>
+                <a:ea typeface="Arial" pitchFamily="34" charset="-122"/>
+                <a:cs typeface="Arial" pitchFamily="34" charset="-120"/>
+              </a:rPr>
+              <a:t>Geschäftsausstattungsrechte inklusive</a:t>
+            </a:r>
+            <a:endParaRPr lang="en-US" sz="1200" dirty="0"/>
+          </a:p>
+        </p:txBody>
+      </p:sp>
     </p:spTree>
   </p:cSld>
   <p:clrMapOvr>
@@ -3551,6 +7011,88 @@
               <a:t>09 Discovery</a:t>
             </a:r>
             <a:endParaRPr lang="en-US" sz="1000" dirty="0"/>
+          </a:p>
+        </p:txBody>
+      </p:sp>
+      <p:sp>
+        <p:nvSpPr>
+          <p:cNvPr id="4" name="Text 2"/>
+          <p:cNvSpPr/>
+          <p:nvPr/>
+        </p:nvSpPr>
+        <p:spPr>
+          <a:xfrm>
+            <a:off x="457200" y="868680"/>
+            <a:ext cx="10972800" cy="502920"/>
+          </a:xfrm>
+          <a:prstGeom prst="rect">
+            <a:avLst/>
+          </a:prstGeom>
+          <a:noFill/>
+          <a:ln/>
+        </p:spPr>
+        <p:txBody>
+          <a:bodyPr wrap="square" rtlCol="0" anchor="t">
+            <a:normAutofit/>
+          </a:bodyPr>
+          <a:lstStyle/>
+          <a:p>
+            <a:pPr indent="0" marL="0">
+              <a:buNone/>
+            </a:pPr>
+            <a:r>
+              <a:rPr lang="en-US" sz="2200" b="1" dirty="0">
+                <a:solidFill>
+                  <a:srgbClr val="1A1A1A"/>
+                </a:solidFill>
+                <a:latin typeface="Arial" pitchFamily="34" charset="0"/>
+                <a:ea typeface="Arial" pitchFamily="34" charset="-122"/>
+                <a:cs typeface="Arial" pitchFamily="34" charset="-120"/>
+              </a:rPr>
+              <a:t>Fragen für das Gespräch.</a:t>
+            </a:r>
+            <a:endParaRPr lang="en-US" sz="2200" dirty="0"/>
+          </a:p>
+        </p:txBody>
+      </p:sp>
+      <p:sp>
+        <p:nvSpPr>
+          <p:cNvPr id="5" name="Text 3"/>
+          <p:cNvSpPr/>
+          <p:nvPr/>
+        </p:nvSpPr>
+        <p:spPr>
+          <a:xfrm>
+            <a:off x="457200" y="1481328"/>
+            <a:ext cx="10972800" cy="502920"/>
+          </a:xfrm>
+          <a:prstGeom prst="rect">
+            <a:avLst/>
+          </a:prstGeom>
+          <a:noFill/>
+          <a:ln/>
+        </p:spPr>
+        <p:txBody>
+          <a:bodyPr wrap="square" rtlCol="0" anchor="t">
+            <a:normAutofit/>
+          </a:bodyPr>
+          <a:lstStyle/>
+          <a:p>
+            <a:pPr indent="0" marL="0">
+              <a:buNone/>
+            </a:pPr>
+            <a:r>
+              <a:rPr lang="en-US" sz="1300" dirty="0">
+                <a:solidFill>
+                  <a:srgbClr val="4A4A4A"/>
+                </a:solidFill>
+                <a:latin typeface="Arial" pitchFamily="34" charset="0"/>
+                <a:ea typeface="Arial" pitchFamily="34" charset="-122"/>
+                <a:cs typeface="Arial" pitchFamily="34" charset="-120"/>
+              </a:rPr>
+              <a:t>Sieben Fragen, in Reihenfolge. Die erste öffnet jedes Gespräch. Die letzte schließt die meisten.</a:t>
+            </a:r>
+            <a:endParaRPr lang="en-US" sz="1300" dirty="0"/>
           </a:p>
         </p:txBody>
       </p:sp>

</xml_diff>